<commit_message>
Ship optional Evidence after Documents, periodic draft recall, and SOD writing-deck pack labels.
Investigators can open IR/SOD without exhibits, restore from recall points if the network drops, and SOD export follows the writing-deck evidence forms without treating that deck as statute authority.

Co-authored-by: Cursor <cursoragent@cursor.com>
</commit_message>
<xml_diff>
--- a/data/examples/policy_guidance/Behavioral Health SOD Writing.pptx
+++ b/data/examples/policy_guidance/Behavioral Health SOD Writing.pptx
@@ -2,31 +2,31 @@
 <file path=ppt/presentation.xml><?xml version="1.0" encoding="utf-8"?>
 <p:presentation xmlns:a="http://schemas.openxmlformats.org/drawingml/2006/main" xmlns:r="http://schemas.openxmlformats.org/officeDocument/2006/relationships" xmlns:p="http://schemas.openxmlformats.org/presentationml/2006/main" autoCompressPictures="0">
   <p:sldMasterIdLst>
-    <p:sldMasterId id="2147483648" r:id="rId4"/>
+    <p:sldMasterId id="2147483648" r:id="rId5"/>
   </p:sldMasterIdLst>
   <p:sldIdLst>
-    <p:sldId id="270" r:id="rId5"/>
-    <p:sldId id="258" r:id="rId6"/>
-    <p:sldId id="260" r:id="rId7"/>
-    <p:sldId id="274" r:id="rId8"/>
-    <p:sldId id="261" r:id="rId9"/>
-    <p:sldId id="276" r:id="rId10"/>
-    <p:sldId id="262" r:id="rId11"/>
-    <p:sldId id="277" r:id="rId12"/>
-    <p:sldId id="264" r:id="rId13"/>
-    <p:sldId id="284" r:id="rId14"/>
-    <p:sldId id="265" r:id="rId15"/>
-    <p:sldId id="279" r:id="rId16"/>
-    <p:sldId id="266" r:id="rId17"/>
-    <p:sldId id="280" r:id="rId18"/>
-    <p:sldId id="267" r:id="rId19"/>
-    <p:sldId id="281" r:id="rId20"/>
-    <p:sldId id="268" r:id="rId21"/>
-    <p:sldId id="271" r:id="rId22"/>
-    <p:sldId id="272" r:id="rId23"/>
-    <p:sldId id="273" r:id="rId24"/>
-    <p:sldId id="282" r:id="rId25"/>
-    <p:sldId id="283" r:id="rId26"/>
+    <p:sldId id="270" r:id="rId6"/>
+    <p:sldId id="258" r:id="rId7"/>
+    <p:sldId id="260" r:id="rId8"/>
+    <p:sldId id="274" r:id="rId9"/>
+    <p:sldId id="261" r:id="rId10"/>
+    <p:sldId id="276" r:id="rId11"/>
+    <p:sldId id="262" r:id="rId12"/>
+    <p:sldId id="277" r:id="rId13"/>
+    <p:sldId id="264" r:id="rId14"/>
+    <p:sldId id="284" r:id="rId15"/>
+    <p:sldId id="265" r:id="rId16"/>
+    <p:sldId id="279" r:id="rId17"/>
+    <p:sldId id="266" r:id="rId18"/>
+    <p:sldId id="280" r:id="rId19"/>
+    <p:sldId id="267" r:id="rId20"/>
+    <p:sldId id="281" r:id="rId21"/>
+    <p:sldId id="268" r:id="rId22"/>
+    <p:sldId id="271" r:id="rId23"/>
+    <p:sldId id="272" r:id="rId24"/>
+    <p:sldId id="273" r:id="rId25"/>
+    <p:sldId id="282" r:id="rId26"/>
+    <p:sldId id="283" r:id="rId27"/>
   </p:sldIdLst>
   <p:sldSz cx="12192000" cy="6858000"/>
   <p:notesSz cx="6858000" cy="9144000"/>
@@ -148,6 +148,22 @@
           <pc:docMk/>
           <pc:sldMk cId="487920764" sldId="258"/>
         </pc:sldMkLst>
+        <pc:spChg chg="mod">
+          <ac:chgData name="Todd, Suzanne C  (DOH)" userId="af71578b-69d5-433a-9be5-dc8fe9528ab1" providerId="ADAL" clId="{F909BB2F-CC95-42AC-BCEF-9352AD515805}" dt="2023-07-28T16:32:07.118" v="72" actId="20577"/>
+          <ac:spMkLst>
+            <pc:docMk/>
+            <pc:sldMk cId="487920764" sldId="258"/>
+            <ac:spMk id="3" creationId="{00000000-0000-0000-0000-000000000000}"/>
+          </ac:spMkLst>
+        </pc:spChg>
+        <pc:spChg chg="mod">
+          <ac:chgData name="Todd, Suzanne C  (DOH)" userId="af71578b-69d5-433a-9be5-dc8fe9528ab1" providerId="ADAL" clId="{F909BB2F-CC95-42AC-BCEF-9352AD515805}" dt="2023-07-28T16:35:05.846" v="78" actId="6549"/>
+          <ac:spMkLst>
+            <pc:docMk/>
+            <pc:sldMk cId="487920764" sldId="258"/>
+            <ac:spMk id="4" creationId="{00000000-0000-0000-0000-000000000000}"/>
+          </ac:spMkLst>
+        </pc:spChg>
       </pc:sldChg>
       <pc:sldChg chg="modSp mod">
         <pc:chgData name="Todd, Suzanne C  (DOH)" userId="af71578b-69d5-433a-9be5-dc8fe9528ab1" providerId="ADAL" clId="{F909BB2F-CC95-42AC-BCEF-9352AD515805}" dt="2023-07-28T16:44:07.060" v="401" actId="33524"/>
@@ -155,6 +171,22 @@
           <pc:docMk/>
           <pc:sldMk cId="234459859" sldId="260"/>
         </pc:sldMkLst>
+        <pc:spChg chg="mod">
+          <ac:chgData name="Todd, Suzanne C  (DOH)" userId="af71578b-69d5-433a-9be5-dc8fe9528ab1" providerId="ADAL" clId="{F909BB2F-CC95-42AC-BCEF-9352AD515805}" dt="2023-07-28T16:38:17.683" v="102" actId="20577"/>
+          <ac:spMkLst>
+            <pc:docMk/>
+            <pc:sldMk cId="234459859" sldId="260"/>
+            <ac:spMk id="2" creationId="{00000000-0000-0000-0000-000000000000}"/>
+          </ac:spMkLst>
+        </pc:spChg>
+        <pc:spChg chg="mod">
+          <ac:chgData name="Todd, Suzanne C  (DOH)" userId="af71578b-69d5-433a-9be5-dc8fe9528ab1" providerId="ADAL" clId="{F909BB2F-CC95-42AC-BCEF-9352AD515805}" dt="2023-07-28T16:44:07.060" v="401" actId="33524"/>
+          <ac:spMkLst>
+            <pc:docMk/>
+            <pc:sldMk cId="234459859" sldId="260"/>
+            <ac:spMk id="4" creationId="{00000000-0000-0000-0000-000000000000}"/>
+          </ac:spMkLst>
+        </pc:spChg>
       </pc:sldChg>
       <pc:sldChg chg="modSp mod">
         <pc:chgData name="Todd, Suzanne C  (DOH)" userId="af71578b-69d5-433a-9be5-dc8fe9528ab1" providerId="ADAL" clId="{F909BB2F-CC95-42AC-BCEF-9352AD515805}" dt="2023-07-28T16:59:01.753" v="677" actId="20577"/>
@@ -162,6 +194,22 @@
           <pc:docMk/>
           <pc:sldMk cId="3663717395" sldId="261"/>
         </pc:sldMkLst>
+        <pc:spChg chg="mod">
+          <ac:chgData name="Todd, Suzanne C  (DOH)" userId="af71578b-69d5-433a-9be5-dc8fe9528ab1" providerId="ADAL" clId="{F909BB2F-CC95-42AC-BCEF-9352AD515805}" dt="2023-07-28T16:55:46.971" v="511" actId="20577"/>
+          <ac:spMkLst>
+            <pc:docMk/>
+            <pc:sldMk cId="3663717395" sldId="261"/>
+            <ac:spMk id="2" creationId="{00000000-0000-0000-0000-000000000000}"/>
+          </ac:spMkLst>
+        </pc:spChg>
+        <pc:spChg chg="mod">
+          <ac:chgData name="Todd, Suzanne C  (DOH)" userId="af71578b-69d5-433a-9be5-dc8fe9528ab1" providerId="ADAL" clId="{F909BB2F-CC95-42AC-BCEF-9352AD515805}" dt="2023-07-28T16:59:01.753" v="677" actId="20577"/>
+          <ac:spMkLst>
+            <pc:docMk/>
+            <pc:sldMk cId="3663717395" sldId="261"/>
+            <ac:spMk id="4" creationId="{00000000-0000-0000-0000-000000000000}"/>
+          </ac:spMkLst>
+        </pc:spChg>
       </pc:sldChg>
       <pc:sldChg chg="modSp mod">
         <pc:chgData name="Todd, Suzanne C  (DOH)" userId="af71578b-69d5-433a-9be5-dc8fe9528ab1" providerId="ADAL" clId="{F909BB2F-CC95-42AC-BCEF-9352AD515805}" dt="2023-07-28T17:17:04.527" v="935" actId="20577"/>
@@ -169,6 +217,22 @@
           <pc:docMk/>
           <pc:sldMk cId="3332275302" sldId="262"/>
         </pc:sldMkLst>
+        <pc:spChg chg="mod">
+          <ac:chgData name="Todd, Suzanne C  (DOH)" userId="af71578b-69d5-433a-9be5-dc8fe9528ab1" providerId="ADAL" clId="{F909BB2F-CC95-42AC-BCEF-9352AD515805}" dt="2023-07-28T17:17:04.527" v="935" actId="20577"/>
+          <ac:spMkLst>
+            <pc:docMk/>
+            <pc:sldMk cId="3332275302" sldId="262"/>
+            <ac:spMk id="4" creationId="{00000000-0000-0000-0000-000000000000}"/>
+          </ac:spMkLst>
+        </pc:spChg>
+        <pc:picChg chg="mod">
+          <ac:chgData name="Todd, Suzanne C  (DOH)" userId="af71578b-69d5-433a-9be5-dc8fe9528ab1" providerId="ADAL" clId="{F909BB2F-CC95-42AC-BCEF-9352AD515805}" dt="2023-07-28T17:16:29.569" v="922" actId="14826"/>
+          <ac:picMkLst>
+            <pc:docMk/>
+            <pc:sldMk cId="3332275302" sldId="262"/>
+            <ac:picMk id="5" creationId="{00000000-0000-0000-0000-000000000000}"/>
+          </ac:picMkLst>
+        </pc:picChg>
       </pc:sldChg>
       <pc:sldChg chg="modSp mod">
         <pc:chgData name="Todd, Suzanne C  (DOH)" userId="af71578b-69d5-433a-9be5-dc8fe9528ab1" providerId="ADAL" clId="{F909BB2F-CC95-42AC-BCEF-9352AD515805}" dt="2023-07-29T23:06:16.070" v="975" actId="20577"/>
@@ -176,6 +240,14 @@
           <pc:docMk/>
           <pc:sldMk cId="3625022557" sldId="264"/>
         </pc:sldMkLst>
+        <pc:spChg chg="mod">
+          <ac:chgData name="Todd, Suzanne C  (DOH)" userId="af71578b-69d5-433a-9be5-dc8fe9528ab1" providerId="ADAL" clId="{F909BB2F-CC95-42AC-BCEF-9352AD515805}" dt="2023-07-29T23:06:16.070" v="975" actId="20577"/>
+          <ac:spMkLst>
+            <pc:docMk/>
+            <pc:sldMk cId="3625022557" sldId="264"/>
+            <ac:spMk id="6" creationId="{00000000-0000-0000-0000-000000000000}"/>
+          </ac:spMkLst>
+        </pc:spChg>
       </pc:sldChg>
       <pc:sldChg chg="modSp mod">
         <pc:chgData name="Todd, Suzanne C  (DOH)" userId="af71578b-69d5-433a-9be5-dc8fe9528ab1" providerId="ADAL" clId="{F909BB2F-CC95-42AC-BCEF-9352AD515805}" dt="2023-08-15T15:17:06.349" v="1849" actId="1076"/>
@@ -183,6 +255,30 @@
           <pc:docMk/>
           <pc:sldMk cId="553003364" sldId="265"/>
         </pc:sldMkLst>
+        <pc:spChg chg="mod">
+          <ac:chgData name="Todd, Suzanne C  (DOH)" userId="af71578b-69d5-433a-9be5-dc8fe9528ab1" providerId="ADAL" clId="{F909BB2F-CC95-42AC-BCEF-9352AD515805}" dt="2023-08-15T15:17:04.831" v="1848" actId="20577"/>
+          <ac:spMkLst>
+            <pc:docMk/>
+            <pc:sldMk cId="553003364" sldId="265"/>
+            <ac:spMk id="2" creationId="{00000000-0000-0000-0000-000000000000}"/>
+          </ac:spMkLst>
+        </pc:spChg>
+        <pc:spChg chg="mod">
+          <ac:chgData name="Todd, Suzanne C  (DOH)" userId="af71578b-69d5-433a-9be5-dc8fe9528ab1" providerId="ADAL" clId="{F909BB2F-CC95-42AC-BCEF-9352AD515805}" dt="2023-07-29T23:19:55.027" v="1124" actId="20577"/>
+          <ac:spMkLst>
+            <pc:docMk/>
+            <pc:sldMk cId="553003364" sldId="265"/>
+            <ac:spMk id="4" creationId="{00000000-0000-0000-0000-000000000000}"/>
+          </ac:spMkLst>
+        </pc:spChg>
+        <pc:picChg chg="mod">
+          <ac:chgData name="Todd, Suzanne C  (DOH)" userId="af71578b-69d5-433a-9be5-dc8fe9528ab1" providerId="ADAL" clId="{F909BB2F-CC95-42AC-BCEF-9352AD515805}" dt="2023-08-15T15:17:06.349" v="1849" actId="1076"/>
+          <ac:picMkLst>
+            <pc:docMk/>
+            <pc:sldMk cId="553003364" sldId="265"/>
+            <ac:picMk id="5" creationId="{00000000-0000-0000-0000-000000000000}"/>
+          </ac:picMkLst>
+        </pc:picChg>
       </pc:sldChg>
       <pc:sldChg chg="modSp mod">
         <pc:chgData name="Todd, Suzanne C  (DOH)" userId="af71578b-69d5-433a-9be5-dc8fe9528ab1" providerId="ADAL" clId="{F909BB2F-CC95-42AC-BCEF-9352AD515805}" dt="2023-07-29T23:38:25.784" v="1358" actId="6549"/>
@@ -190,6 +286,14 @@
           <pc:docMk/>
           <pc:sldMk cId="4084762284" sldId="267"/>
         </pc:sldMkLst>
+        <pc:spChg chg="mod">
+          <ac:chgData name="Todd, Suzanne C  (DOH)" userId="af71578b-69d5-433a-9be5-dc8fe9528ab1" providerId="ADAL" clId="{F909BB2F-CC95-42AC-BCEF-9352AD515805}" dt="2023-07-29T23:38:25.784" v="1358" actId="6549"/>
+          <ac:spMkLst>
+            <pc:docMk/>
+            <pc:sldMk cId="4084762284" sldId="267"/>
+            <ac:spMk id="3" creationId="{00000000-0000-0000-0000-000000000000}"/>
+          </ac:spMkLst>
+        </pc:spChg>
       </pc:sldChg>
       <pc:sldChg chg="modSp mod">
         <pc:chgData name="Todd, Suzanne C  (DOH)" userId="af71578b-69d5-433a-9be5-dc8fe9528ab1" providerId="ADAL" clId="{F909BB2F-CC95-42AC-BCEF-9352AD515805}" dt="2023-07-29T23:49:39.869" v="1509" actId="13926"/>
@@ -197,6 +301,14 @@
           <pc:docMk/>
           <pc:sldMk cId="1368993529" sldId="268"/>
         </pc:sldMkLst>
+        <pc:spChg chg="mod">
+          <ac:chgData name="Todd, Suzanne C  (DOH)" userId="af71578b-69d5-433a-9be5-dc8fe9528ab1" providerId="ADAL" clId="{F909BB2F-CC95-42AC-BCEF-9352AD515805}" dt="2023-07-29T23:49:39.869" v="1509" actId="13926"/>
+          <ac:spMkLst>
+            <pc:docMk/>
+            <pc:sldMk cId="1368993529" sldId="268"/>
+            <ac:spMk id="4" creationId="{00000000-0000-0000-0000-000000000000}"/>
+          </ac:spMkLst>
+        </pc:spChg>
       </pc:sldChg>
       <pc:sldChg chg="del">
         <pc:chgData name="Todd, Suzanne C  (DOH)" userId="af71578b-69d5-433a-9be5-dc8fe9528ab1" providerId="ADAL" clId="{F909BB2F-CC95-42AC-BCEF-9352AD515805}" dt="2023-07-29T23:49:56.935" v="1510" actId="2696"/>
@@ -211,6 +323,14 @@
           <pc:docMk/>
           <pc:sldMk cId="3071771991" sldId="271"/>
         </pc:sldMkLst>
+        <pc:spChg chg="mod">
+          <ac:chgData name="Todd, Suzanne C  (DOH)" userId="af71578b-69d5-433a-9be5-dc8fe9528ab1" providerId="ADAL" clId="{F909BB2F-CC95-42AC-BCEF-9352AD515805}" dt="2023-07-29T23:50:24.768" v="1512" actId="27636"/>
+          <ac:spMkLst>
+            <pc:docMk/>
+            <pc:sldMk cId="3071771991" sldId="271"/>
+            <ac:spMk id="4" creationId="{00000000-0000-0000-0000-000000000000}"/>
+          </ac:spMkLst>
+        </pc:spChg>
       </pc:sldChg>
       <pc:sldChg chg="modSp mod">
         <pc:chgData name="Todd, Suzanne C  (DOH)" userId="af71578b-69d5-433a-9be5-dc8fe9528ab1" providerId="ADAL" clId="{F909BB2F-CC95-42AC-BCEF-9352AD515805}" dt="2023-07-29T23:51:04.358" v="1514" actId="6549"/>
@@ -218,6 +338,14 @@
           <pc:docMk/>
           <pc:sldMk cId="3730851998" sldId="273"/>
         </pc:sldMkLst>
+        <pc:spChg chg="mod">
+          <ac:chgData name="Todd, Suzanne C  (DOH)" userId="af71578b-69d5-433a-9be5-dc8fe9528ab1" providerId="ADAL" clId="{F909BB2F-CC95-42AC-BCEF-9352AD515805}" dt="2023-07-29T23:51:04.358" v="1514" actId="6549"/>
+          <ac:spMkLst>
+            <pc:docMk/>
+            <pc:sldMk cId="3730851998" sldId="273"/>
+            <ac:spMk id="4" creationId="{00000000-0000-0000-0000-000000000000}"/>
+          </ac:spMkLst>
+        </pc:spChg>
       </pc:sldChg>
       <pc:sldChg chg="addSp delSp modSp new mod modClrScheme chgLayout">
         <pc:chgData name="Todd, Suzanne C  (DOH)" userId="af71578b-69d5-433a-9be5-dc8fe9528ab1" providerId="ADAL" clId="{F909BB2F-CC95-42AC-BCEF-9352AD515805}" dt="2023-07-28T17:00:14.291" v="712" actId="14734"/>
@@ -225,6 +353,86 @@
           <pc:docMk/>
           <pc:sldMk cId="1748972345" sldId="274"/>
         </pc:sldMkLst>
+        <pc:spChg chg="del">
+          <ac:chgData name="Todd, Suzanne C  (DOH)" userId="af71578b-69d5-433a-9be5-dc8fe9528ab1" providerId="ADAL" clId="{F909BB2F-CC95-42AC-BCEF-9352AD515805}" dt="2023-07-28T16:44:30.446" v="403" actId="700"/>
+          <ac:spMkLst>
+            <pc:docMk/>
+            <pc:sldMk cId="1748972345" sldId="274"/>
+            <ac:spMk id="2" creationId="{435ADD33-3787-C583-1943-E28037283D88}"/>
+          </ac:spMkLst>
+        </pc:spChg>
+        <pc:spChg chg="del">
+          <ac:chgData name="Todd, Suzanne C  (DOH)" userId="af71578b-69d5-433a-9be5-dc8fe9528ab1" providerId="ADAL" clId="{F909BB2F-CC95-42AC-BCEF-9352AD515805}" dt="2023-07-28T16:44:30.446" v="403" actId="700"/>
+          <ac:spMkLst>
+            <pc:docMk/>
+            <pc:sldMk cId="1748972345" sldId="274"/>
+            <ac:spMk id="3" creationId="{7EE21C7E-7C25-EE68-46E1-67EC91DC4CEE}"/>
+          </ac:spMkLst>
+        </pc:spChg>
+        <pc:spChg chg="del">
+          <ac:chgData name="Todd, Suzanne C  (DOH)" userId="af71578b-69d5-433a-9be5-dc8fe9528ab1" providerId="ADAL" clId="{F909BB2F-CC95-42AC-BCEF-9352AD515805}" dt="2023-07-28T16:44:30.446" v="403" actId="700"/>
+          <ac:spMkLst>
+            <pc:docMk/>
+            <pc:sldMk cId="1748972345" sldId="274"/>
+            <ac:spMk id="4" creationId="{A0B9F5A3-67DF-7CE7-8A22-61838FE6D8C5}"/>
+          </ac:spMkLst>
+        </pc:spChg>
+        <pc:spChg chg="add mod">
+          <ac:chgData name="Todd, Suzanne C  (DOH)" userId="af71578b-69d5-433a-9be5-dc8fe9528ab1" providerId="ADAL" clId="{F909BB2F-CC95-42AC-BCEF-9352AD515805}" dt="2023-07-28T16:48:13.786" v="456" actId="20577"/>
+          <ac:spMkLst>
+            <pc:docMk/>
+            <pc:sldMk cId="1748972345" sldId="274"/>
+            <ac:spMk id="5" creationId="{D8DF5E9A-5780-E496-5ACB-EF16EC2F4C16}"/>
+          </ac:spMkLst>
+        </pc:spChg>
+        <pc:spChg chg="add mod">
+          <ac:chgData name="Todd, Suzanne C  (DOH)" userId="af71578b-69d5-433a-9be5-dc8fe9528ab1" providerId="ADAL" clId="{F909BB2F-CC95-42AC-BCEF-9352AD515805}" dt="2023-07-28T16:47:53.736" v="404" actId="700"/>
+          <ac:spMkLst>
+            <pc:docMk/>
+            <pc:sldMk cId="1748972345" sldId="274"/>
+            <ac:spMk id="6" creationId="{EBA0D511-B87A-816C-A78C-69A833BE893D}"/>
+          </ac:spMkLst>
+        </pc:spChg>
+        <pc:spChg chg="add mod">
+          <ac:chgData name="Todd, Suzanne C  (DOH)" userId="af71578b-69d5-433a-9be5-dc8fe9528ab1" providerId="ADAL" clId="{F909BB2F-CC95-42AC-BCEF-9352AD515805}" dt="2023-07-28T16:47:53.736" v="404" actId="700"/>
+          <ac:spMkLst>
+            <pc:docMk/>
+            <pc:sldMk cId="1748972345" sldId="274"/>
+            <ac:spMk id="7" creationId="{F4D7138A-1B4B-F8B4-6C43-9B03747EC664}"/>
+          </ac:spMkLst>
+        </pc:spChg>
+        <pc:spChg chg="add del mod">
+          <ac:chgData name="Todd, Suzanne C  (DOH)" userId="af71578b-69d5-433a-9be5-dc8fe9528ab1" providerId="ADAL" clId="{F909BB2F-CC95-42AC-BCEF-9352AD515805}" dt="2023-07-28T16:48:28.539" v="457"/>
+          <ac:spMkLst>
+            <pc:docMk/>
+            <pc:sldMk cId="1748972345" sldId="274"/>
+            <ac:spMk id="8" creationId="{4EB176FC-CC84-99E2-B89E-4ABF7866281C}"/>
+          </ac:spMkLst>
+        </pc:spChg>
+        <pc:spChg chg="add del mod">
+          <ac:chgData name="Todd, Suzanne C  (DOH)" userId="af71578b-69d5-433a-9be5-dc8fe9528ab1" providerId="ADAL" clId="{F909BB2F-CC95-42AC-BCEF-9352AD515805}" dt="2023-07-28T16:49:34.968" v="461"/>
+          <ac:spMkLst>
+            <pc:docMk/>
+            <pc:sldMk cId="1748972345" sldId="274"/>
+            <ac:spMk id="9" creationId="{0BF7B824-BCE9-FB24-C737-6EA4284E5FD2}"/>
+          </ac:spMkLst>
+        </pc:spChg>
+        <pc:graphicFrameChg chg="add mod modGraphic">
+          <ac:chgData name="Todd, Suzanne C  (DOH)" userId="af71578b-69d5-433a-9be5-dc8fe9528ab1" providerId="ADAL" clId="{F909BB2F-CC95-42AC-BCEF-9352AD515805}" dt="2023-07-28T17:00:14.291" v="712" actId="14734"/>
+          <ac:graphicFrameMkLst>
+            <pc:docMk/>
+            <pc:sldMk cId="1748972345" sldId="274"/>
+            <ac:graphicFrameMk id="10" creationId="{CA94B255-E25B-1F1C-9148-8E4D3805DD9B}"/>
+          </ac:graphicFrameMkLst>
+        </pc:graphicFrameChg>
+        <pc:graphicFrameChg chg="add mod modGraphic">
+          <ac:chgData name="Todd, Suzanne C  (DOH)" userId="af71578b-69d5-433a-9be5-dc8fe9528ab1" providerId="ADAL" clId="{F909BB2F-CC95-42AC-BCEF-9352AD515805}" dt="2023-07-28T16:54:38.975" v="486" actId="13926"/>
+          <ac:graphicFrameMkLst>
+            <pc:docMk/>
+            <pc:sldMk cId="1748972345" sldId="274"/>
+            <ac:graphicFrameMk id="11" creationId="{ECDBD5A8-0E72-13A6-E80C-3E26FE5A6810}"/>
+          </ac:graphicFrameMkLst>
+        </pc:graphicFrameChg>
       </pc:sldChg>
       <pc:sldChg chg="addSp delSp modSp new del mod modClrScheme chgLayout">
         <pc:chgData name="Todd, Suzanne C  (DOH)" userId="af71578b-69d5-433a-9be5-dc8fe9528ab1" providerId="ADAL" clId="{F909BB2F-CC95-42AC-BCEF-9352AD515805}" dt="2023-07-28T17:03:12.245" v="746" actId="2696"/>
@@ -232,6 +440,182 @@
           <pc:docMk/>
           <pc:sldMk cId="2909253051" sldId="275"/>
         </pc:sldMkLst>
+        <pc:spChg chg="del">
+          <ac:chgData name="Todd, Suzanne C  (DOH)" userId="af71578b-69d5-433a-9be5-dc8fe9528ab1" providerId="ADAL" clId="{F909BB2F-CC95-42AC-BCEF-9352AD515805}" dt="2023-07-28T16:59:18.799" v="679" actId="700"/>
+          <ac:spMkLst>
+            <pc:docMk/>
+            <pc:sldMk cId="2909253051" sldId="275"/>
+            <ac:spMk id="2" creationId="{0844B9C8-24A4-6B5B-CD13-5FEC7B91CA76}"/>
+          </ac:spMkLst>
+        </pc:spChg>
+        <pc:spChg chg="del">
+          <ac:chgData name="Todd, Suzanne C  (DOH)" userId="af71578b-69d5-433a-9be5-dc8fe9528ab1" providerId="ADAL" clId="{F909BB2F-CC95-42AC-BCEF-9352AD515805}" dt="2023-07-28T16:59:18.799" v="679" actId="700"/>
+          <ac:spMkLst>
+            <pc:docMk/>
+            <pc:sldMk cId="2909253051" sldId="275"/>
+            <ac:spMk id="3" creationId="{CE5AF45D-FB15-A86D-A75F-08C3F56CEB90}"/>
+          </ac:spMkLst>
+        </pc:spChg>
+        <pc:spChg chg="del">
+          <ac:chgData name="Todd, Suzanne C  (DOH)" userId="af71578b-69d5-433a-9be5-dc8fe9528ab1" providerId="ADAL" clId="{F909BB2F-CC95-42AC-BCEF-9352AD515805}" dt="2023-07-28T16:59:18.799" v="679" actId="700"/>
+          <ac:spMkLst>
+            <pc:docMk/>
+            <pc:sldMk cId="2909253051" sldId="275"/>
+            <ac:spMk id="4" creationId="{588619E5-CC84-6E98-B22F-BA3FB41D682C}"/>
+          </ac:spMkLst>
+        </pc:spChg>
+        <pc:spChg chg="add del mod ord">
+          <ac:chgData name="Todd, Suzanne C  (DOH)" userId="af71578b-69d5-433a-9be5-dc8fe9528ab1" providerId="ADAL" clId="{F909BB2F-CC95-42AC-BCEF-9352AD515805}" dt="2023-07-28T16:59:27.070" v="680" actId="700"/>
+          <ac:spMkLst>
+            <pc:docMk/>
+            <pc:sldMk cId="2909253051" sldId="275"/>
+            <ac:spMk id="5" creationId="{C637B55A-CBD4-2C1C-02B5-194B4129561E}"/>
+          </ac:spMkLst>
+        </pc:spChg>
+        <pc:spChg chg="add del mod ord">
+          <ac:chgData name="Todd, Suzanne C  (DOH)" userId="af71578b-69d5-433a-9be5-dc8fe9528ab1" providerId="ADAL" clId="{F909BB2F-CC95-42AC-BCEF-9352AD515805}" dt="2023-07-28T16:59:27.070" v="680" actId="700"/>
+          <ac:spMkLst>
+            <pc:docMk/>
+            <pc:sldMk cId="2909253051" sldId="275"/>
+            <ac:spMk id="6" creationId="{B2A6C66A-34EF-2739-221A-739CD27A7FAA}"/>
+          </ac:spMkLst>
+        </pc:spChg>
+        <pc:spChg chg="add del mod ord">
+          <ac:chgData name="Todd, Suzanne C  (DOH)" userId="af71578b-69d5-433a-9be5-dc8fe9528ab1" providerId="ADAL" clId="{F909BB2F-CC95-42AC-BCEF-9352AD515805}" dt="2023-07-28T16:59:27.070" v="680" actId="700"/>
+          <ac:spMkLst>
+            <pc:docMk/>
+            <pc:sldMk cId="2909253051" sldId="275"/>
+            <ac:spMk id="7" creationId="{B556C39F-D5CC-7D3D-D253-E3F4692F99C5}"/>
+          </ac:spMkLst>
+        </pc:spChg>
+        <pc:spChg chg="add del mod ord">
+          <ac:chgData name="Todd, Suzanne C  (DOH)" userId="af71578b-69d5-433a-9be5-dc8fe9528ab1" providerId="ADAL" clId="{F909BB2F-CC95-42AC-BCEF-9352AD515805}" dt="2023-07-28T16:59:30.542" v="681" actId="700"/>
+          <ac:spMkLst>
+            <pc:docMk/>
+            <pc:sldMk cId="2909253051" sldId="275"/>
+            <ac:spMk id="8" creationId="{478A140B-1CCF-E6D4-8A43-E4A8B418396A}"/>
+          </ac:spMkLst>
+        </pc:spChg>
+        <pc:spChg chg="add del mod ord">
+          <ac:chgData name="Todd, Suzanne C  (DOH)" userId="af71578b-69d5-433a-9be5-dc8fe9528ab1" providerId="ADAL" clId="{F909BB2F-CC95-42AC-BCEF-9352AD515805}" dt="2023-07-28T16:59:30.542" v="681" actId="700"/>
+          <ac:spMkLst>
+            <pc:docMk/>
+            <pc:sldMk cId="2909253051" sldId="275"/>
+            <ac:spMk id="9" creationId="{4BC2477C-5497-483C-E223-88B96376709A}"/>
+          </ac:spMkLst>
+        </pc:spChg>
+        <pc:spChg chg="add del mod ord">
+          <ac:chgData name="Todd, Suzanne C  (DOH)" userId="af71578b-69d5-433a-9be5-dc8fe9528ab1" providerId="ADAL" clId="{F909BB2F-CC95-42AC-BCEF-9352AD515805}" dt="2023-07-28T16:59:30.542" v="681" actId="700"/>
+          <ac:spMkLst>
+            <pc:docMk/>
+            <pc:sldMk cId="2909253051" sldId="275"/>
+            <ac:spMk id="10" creationId="{94E6598F-F77B-BE8F-FE7E-BDEC859C6A91}"/>
+          </ac:spMkLst>
+        </pc:spChg>
+        <pc:spChg chg="add mod ord">
+          <ac:chgData name="Todd, Suzanne C  (DOH)" userId="af71578b-69d5-433a-9be5-dc8fe9528ab1" providerId="ADAL" clId="{F909BB2F-CC95-42AC-BCEF-9352AD515805}" dt="2023-07-28T17:02:45.592" v="742" actId="700"/>
+          <ac:spMkLst>
+            <pc:docMk/>
+            <pc:sldMk cId="2909253051" sldId="275"/>
+            <ac:spMk id="11" creationId="{A150087D-3599-2E41-2988-0CD17C31F306}"/>
+          </ac:spMkLst>
+        </pc:spChg>
+        <pc:spChg chg="add del mod ord">
+          <ac:chgData name="Todd, Suzanne C  (DOH)" userId="af71578b-69d5-433a-9be5-dc8fe9528ab1" providerId="ADAL" clId="{F909BB2F-CC95-42AC-BCEF-9352AD515805}" dt="2023-07-28T17:02:04.140" v="738" actId="700"/>
+          <ac:spMkLst>
+            <pc:docMk/>
+            <pc:sldMk cId="2909253051" sldId="275"/>
+            <ac:spMk id="12" creationId="{FA4102A9-BCD5-B016-8154-B8B29B581393}"/>
+          </ac:spMkLst>
+        </pc:spChg>
+        <pc:spChg chg="add del mod ord">
+          <ac:chgData name="Todd, Suzanne C  (DOH)" userId="af71578b-69d5-433a-9be5-dc8fe9528ab1" providerId="ADAL" clId="{F909BB2F-CC95-42AC-BCEF-9352AD515805}" dt="2023-07-28T17:02:04.140" v="738" actId="700"/>
+          <ac:spMkLst>
+            <pc:docMk/>
+            <pc:sldMk cId="2909253051" sldId="275"/>
+            <ac:spMk id="13" creationId="{E7C8FD90-1774-FDE5-7AF5-1B1A11D3DE59}"/>
+          </ac:spMkLst>
+        </pc:spChg>
+        <pc:spChg chg="add mod ord">
+          <ac:chgData name="Todd, Suzanne C  (DOH)" userId="af71578b-69d5-433a-9be5-dc8fe9528ab1" providerId="ADAL" clId="{F909BB2F-CC95-42AC-BCEF-9352AD515805}" dt="2023-07-28T17:02:55.068" v="745" actId="27636"/>
+          <ac:spMkLst>
+            <pc:docMk/>
+            <pc:sldMk cId="2909253051" sldId="275"/>
+            <ac:spMk id="14" creationId="{9B69C83E-0D65-276F-BA23-209802F85128}"/>
+          </ac:spMkLst>
+        </pc:spChg>
+        <pc:spChg chg="add del mod ord">
+          <ac:chgData name="Todd, Suzanne C  (DOH)" userId="af71578b-69d5-433a-9be5-dc8fe9528ab1" providerId="ADAL" clId="{F909BB2F-CC95-42AC-BCEF-9352AD515805}" dt="2023-07-28T17:02:04.140" v="738" actId="700"/>
+          <ac:spMkLst>
+            <pc:docMk/>
+            <pc:sldMk cId="2909253051" sldId="275"/>
+            <ac:spMk id="15" creationId="{5429DFBD-0B6F-C1FF-A079-F3DDCBBD9B67}"/>
+          </ac:spMkLst>
+        </pc:spChg>
+        <pc:spChg chg="add del mod ord">
+          <ac:chgData name="Todd, Suzanne C  (DOH)" userId="af71578b-69d5-433a-9be5-dc8fe9528ab1" providerId="ADAL" clId="{F909BB2F-CC95-42AC-BCEF-9352AD515805}" dt="2023-07-28T17:02:45.592" v="742" actId="700"/>
+          <ac:spMkLst>
+            <pc:docMk/>
+            <pc:sldMk cId="2909253051" sldId="275"/>
+            <ac:spMk id="16" creationId="{F125E704-A908-7D9B-9B3A-37FEB6744C5C}"/>
+          </ac:spMkLst>
+        </pc:spChg>
+        <pc:spChg chg="add del mod ord">
+          <ac:chgData name="Todd, Suzanne C  (DOH)" userId="af71578b-69d5-433a-9be5-dc8fe9528ab1" providerId="ADAL" clId="{F909BB2F-CC95-42AC-BCEF-9352AD515805}" dt="2023-07-28T17:02:45.592" v="742" actId="700"/>
+          <ac:spMkLst>
+            <pc:docMk/>
+            <pc:sldMk cId="2909253051" sldId="275"/>
+            <ac:spMk id="17" creationId="{6E871350-AFFE-4357-225F-BBBB8E8073A3}"/>
+          </ac:spMkLst>
+        </pc:spChg>
+        <pc:spChg chg="add del mod ord">
+          <ac:chgData name="Todd, Suzanne C  (DOH)" userId="af71578b-69d5-433a-9be5-dc8fe9528ab1" providerId="ADAL" clId="{F909BB2F-CC95-42AC-BCEF-9352AD515805}" dt="2023-07-28T17:02:45.592" v="742" actId="700"/>
+          <ac:spMkLst>
+            <pc:docMk/>
+            <pc:sldMk cId="2909253051" sldId="275"/>
+            <ac:spMk id="18" creationId="{D2D7EE4B-3398-ACFF-319A-20E17F437E25}"/>
+          </ac:spMkLst>
+        </pc:spChg>
+        <pc:spChg chg="add del mod ord">
+          <ac:chgData name="Todd, Suzanne C  (DOH)" userId="af71578b-69d5-433a-9be5-dc8fe9528ab1" providerId="ADAL" clId="{F909BB2F-CC95-42AC-BCEF-9352AD515805}" dt="2023-07-28T17:02:45.592" v="742" actId="700"/>
+          <ac:spMkLst>
+            <pc:docMk/>
+            <pc:sldMk cId="2909253051" sldId="275"/>
+            <ac:spMk id="19" creationId="{D5D476DE-06EC-0801-6842-1F398B16725D}"/>
+          </ac:spMkLst>
+        </pc:spChg>
+        <pc:spChg chg="add del mod ord">
+          <ac:chgData name="Todd, Suzanne C  (DOH)" userId="af71578b-69d5-433a-9be5-dc8fe9528ab1" providerId="ADAL" clId="{F909BB2F-CC95-42AC-BCEF-9352AD515805}" dt="2023-07-28T17:02:45.592" v="742" actId="700"/>
+          <ac:spMkLst>
+            <pc:docMk/>
+            <pc:sldMk cId="2909253051" sldId="275"/>
+            <ac:spMk id="20" creationId="{92FA23E4-8E72-435F-76FA-98F314A57E55}"/>
+          </ac:spMkLst>
+        </pc:spChg>
+        <pc:spChg chg="add mod ord">
+          <ac:chgData name="Todd, Suzanne C  (DOH)" userId="af71578b-69d5-433a-9be5-dc8fe9528ab1" providerId="ADAL" clId="{F909BB2F-CC95-42AC-BCEF-9352AD515805}" dt="2023-07-28T17:02:45.592" v="742" actId="700"/>
+          <ac:spMkLst>
+            <pc:docMk/>
+            <pc:sldMk cId="2909253051" sldId="275"/>
+            <ac:spMk id="21" creationId="{3708092F-45C4-03D3-6DB0-C6C189953274}"/>
+          </ac:spMkLst>
+        </pc:spChg>
+        <pc:spChg chg="add mod ord">
+          <ac:chgData name="Todd, Suzanne C  (DOH)" userId="af71578b-69d5-433a-9be5-dc8fe9528ab1" providerId="ADAL" clId="{F909BB2F-CC95-42AC-BCEF-9352AD515805}" dt="2023-07-28T17:02:45.592" v="742" actId="700"/>
+          <ac:spMkLst>
+            <pc:docMk/>
+            <pc:sldMk cId="2909253051" sldId="275"/>
+            <ac:spMk id="22" creationId="{94D73439-94B3-A6DA-78F1-7444FFEB6E37}"/>
+          </ac:spMkLst>
+        </pc:spChg>
+        <pc:spChg chg="add mod ord">
+          <ac:chgData name="Todd, Suzanne C  (DOH)" userId="af71578b-69d5-433a-9be5-dc8fe9528ab1" providerId="ADAL" clId="{F909BB2F-CC95-42AC-BCEF-9352AD515805}" dt="2023-07-28T17:02:45.592" v="742" actId="700"/>
+          <ac:spMkLst>
+            <pc:docMk/>
+            <pc:sldMk cId="2909253051" sldId="275"/>
+            <ac:spMk id="23" creationId="{CF2E70D0-39EF-4367-08A8-E78FDD928DA4}"/>
+          </ac:spMkLst>
+        </pc:spChg>
       </pc:sldChg>
       <pc:sldChg chg="new del">
         <pc:chgData name="Todd, Suzanne C  (DOH)" userId="af71578b-69d5-433a-9be5-dc8fe9528ab1" providerId="ADAL" clId="{F909BB2F-CC95-42AC-BCEF-9352AD515805}" dt="2023-07-28T17:07:14.664" v="774" actId="2696"/>
@@ -246,6 +630,30 @@
           <pc:docMk/>
           <pc:sldMk cId="1238034687" sldId="276"/>
         </pc:sldMkLst>
+        <pc:spChg chg="mod">
+          <ac:chgData name="Todd, Suzanne C  (DOH)" userId="af71578b-69d5-433a-9be5-dc8fe9528ab1" providerId="ADAL" clId="{F909BB2F-CC95-42AC-BCEF-9352AD515805}" dt="2023-07-28T17:03:37.355" v="760" actId="20577"/>
+          <ac:spMkLst>
+            <pc:docMk/>
+            <pc:sldMk cId="1238034687" sldId="276"/>
+            <ac:spMk id="5" creationId="{D8DF5E9A-5780-E496-5ACB-EF16EC2F4C16}"/>
+          </ac:spMkLst>
+        </pc:spChg>
+        <pc:graphicFrameChg chg="mod modGraphic">
+          <ac:chgData name="Todd, Suzanne C  (DOH)" userId="af71578b-69d5-433a-9be5-dc8fe9528ab1" providerId="ADAL" clId="{F909BB2F-CC95-42AC-BCEF-9352AD515805}" dt="2023-07-28T17:13:35.076" v="869" actId="13926"/>
+          <ac:graphicFrameMkLst>
+            <pc:docMk/>
+            <pc:sldMk cId="1238034687" sldId="276"/>
+            <ac:graphicFrameMk id="10" creationId="{CA94B255-E25B-1F1C-9148-8E4D3805DD9B}"/>
+          </ac:graphicFrameMkLst>
+        </pc:graphicFrameChg>
+        <pc:graphicFrameChg chg="mod modGraphic">
+          <ac:chgData name="Todd, Suzanne C  (DOH)" userId="af71578b-69d5-433a-9be5-dc8fe9528ab1" providerId="ADAL" clId="{F909BB2F-CC95-42AC-BCEF-9352AD515805}" dt="2023-07-28T17:12:32.103" v="866" actId="20577"/>
+          <ac:graphicFrameMkLst>
+            <pc:docMk/>
+            <pc:sldMk cId="1238034687" sldId="276"/>
+            <ac:graphicFrameMk id="11" creationId="{ECDBD5A8-0E72-13A6-E80C-3E26FE5A6810}"/>
+          </ac:graphicFrameMkLst>
+        </pc:graphicFrameChg>
       </pc:sldChg>
       <pc:sldChg chg="addSp delSp modSp new mod modClrScheme chgLayout">
         <pc:chgData name="Todd, Suzanne C  (DOH)" userId="af71578b-69d5-433a-9be5-dc8fe9528ab1" providerId="ADAL" clId="{F909BB2F-CC95-42AC-BCEF-9352AD515805}" dt="2023-07-29T23:05:46.762" v="970" actId="13926"/>
@@ -253,6 +661,46 @@
           <pc:docMk/>
           <pc:sldMk cId="2509298696" sldId="277"/>
         </pc:sldMkLst>
+        <pc:spChg chg="del">
+          <ac:chgData name="Todd, Suzanne C  (DOH)" userId="af71578b-69d5-433a-9be5-dc8fe9528ab1" providerId="ADAL" clId="{F909BB2F-CC95-42AC-BCEF-9352AD515805}" dt="2023-07-28T17:17:25.249" v="937" actId="700"/>
+          <ac:spMkLst>
+            <pc:docMk/>
+            <pc:sldMk cId="2509298696" sldId="277"/>
+            <ac:spMk id="2" creationId="{12CAFF4B-9570-1F07-64CB-61C79A2EA365}"/>
+          </ac:spMkLst>
+        </pc:spChg>
+        <pc:spChg chg="del">
+          <ac:chgData name="Todd, Suzanne C  (DOH)" userId="af71578b-69d5-433a-9be5-dc8fe9528ab1" providerId="ADAL" clId="{F909BB2F-CC95-42AC-BCEF-9352AD515805}" dt="2023-07-28T17:17:25.249" v="937" actId="700"/>
+          <ac:spMkLst>
+            <pc:docMk/>
+            <pc:sldMk cId="2509298696" sldId="277"/>
+            <ac:spMk id="3" creationId="{DDEE988B-A162-03A3-ACDC-32271A1A3C88}"/>
+          </ac:spMkLst>
+        </pc:spChg>
+        <pc:spChg chg="del">
+          <ac:chgData name="Todd, Suzanne C  (DOH)" userId="af71578b-69d5-433a-9be5-dc8fe9528ab1" providerId="ADAL" clId="{F909BB2F-CC95-42AC-BCEF-9352AD515805}" dt="2023-07-28T17:17:25.249" v="937" actId="700"/>
+          <ac:spMkLst>
+            <pc:docMk/>
+            <pc:sldMk cId="2509298696" sldId="277"/>
+            <ac:spMk id="4" creationId="{02D1A681-7FCA-31FE-1704-ABD9D85AEB50}"/>
+          </ac:spMkLst>
+        </pc:spChg>
+        <pc:spChg chg="add mod">
+          <ac:chgData name="Todd, Suzanne C  (DOH)" userId="af71578b-69d5-433a-9be5-dc8fe9528ab1" providerId="ADAL" clId="{F909BB2F-CC95-42AC-BCEF-9352AD515805}" dt="2023-07-28T17:17:44.658" v="957" actId="14100"/>
+          <ac:spMkLst>
+            <pc:docMk/>
+            <pc:sldMk cId="2509298696" sldId="277"/>
+            <ac:spMk id="5" creationId="{B3172581-D972-4117-664D-DA2C24BA4B17}"/>
+          </ac:spMkLst>
+        </pc:spChg>
+        <pc:spChg chg="add mod">
+          <ac:chgData name="Todd, Suzanne C  (DOH)" userId="af71578b-69d5-433a-9be5-dc8fe9528ab1" providerId="ADAL" clId="{F909BB2F-CC95-42AC-BCEF-9352AD515805}" dt="2023-07-29T23:05:46.762" v="970" actId="13926"/>
+          <ac:spMkLst>
+            <pc:docMk/>
+            <pc:sldMk cId="2509298696" sldId="277"/>
+            <ac:spMk id="6" creationId="{2470B95B-9355-2C18-87DD-DD9AACEEABBD}"/>
+          </ac:spMkLst>
+        </pc:spChg>
       </pc:sldChg>
       <pc:sldChg chg="addSp delSp modSp new mod modClrScheme chgLayout">
         <pc:chgData name="Todd, Suzanne C  (DOH)" userId="af71578b-69d5-433a-9be5-dc8fe9528ab1" providerId="ADAL" clId="{F909BB2F-CC95-42AC-BCEF-9352AD515805}" dt="2023-07-29T23:18:32.065" v="1098" actId="20577"/>
@@ -260,6 +708,86 @@
           <pc:docMk/>
           <pc:sldMk cId="2822355169" sldId="278"/>
         </pc:sldMkLst>
+        <pc:spChg chg="del mod ord">
+          <ac:chgData name="Todd, Suzanne C  (DOH)" userId="af71578b-69d5-433a-9be5-dc8fe9528ab1" providerId="ADAL" clId="{F909BB2F-CC95-42AC-BCEF-9352AD515805}" dt="2023-07-29T23:10:10.113" v="977" actId="700"/>
+          <ac:spMkLst>
+            <pc:docMk/>
+            <pc:sldMk cId="2822355169" sldId="278"/>
+            <ac:spMk id="2" creationId="{8D19225D-497C-C193-5448-F2A4AA17E9CD}"/>
+          </ac:spMkLst>
+        </pc:spChg>
+        <pc:spChg chg="del mod ord">
+          <ac:chgData name="Todd, Suzanne C  (DOH)" userId="af71578b-69d5-433a-9be5-dc8fe9528ab1" providerId="ADAL" clId="{F909BB2F-CC95-42AC-BCEF-9352AD515805}" dt="2023-07-29T23:10:10.113" v="977" actId="700"/>
+          <ac:spMkLst>
+            <pc:docMk/>
+            <pc:sldMk cId="2822355169" sldId="278"/>
+            <ac:spMk id="3" creationId="{DA031227-A42E-5DD0-8E7E-7791382AC31B}"/>
+          </ac:spMkLst>
+        </pc:spChg>
+        <pc:spChg chg="del">
+          <ac:chgData name="Todd, Suzanne C  (DOH)" userId="af71578b-69d5-433a-9be5-dc8fe9528ab1" providerId="ADAL" clId="{F909BB2F-CC95-42AC-BCEF-9352AD515805}" dt="2023-07-29T23:10:10.113" v="977" actId="700"/>
+          <ac:spMkLst>
+            <pc:docMk/>
+            <pc:sldMk cId="2822355169" sldId="278"/>
+            <ac:spMk id="4" creationId="{F1246E61-C7E9-D76B-D5D8-5DB9BA69322B}"/>
+          </ac:spMkLst>
+        </pc:spChg>
+        <pc:spChg chg="del">
+          <ac:chgData name="Todd, Suzanne C  (DOH)" userId="af71578b-69d5-433a-9be5-dc8fe9528ab1" providerId="ADAL" clId="{F909BB2F-CC95-42AC-BCEF-9352AD515805}" dt="2023-07-29T23:10:10.113" v="977" actId="700"/>
+          <ac:spMkLst>
+            <pc:docMk/>
+            <pc:sldMk cId="2822355169" sldId="278"/>
+            <ac:spMk id="5" creationId="{A66DAD34-950E-881A-075F-D8FA30EFF30C}"/>
+          </ac:spMkLst>
+        </pc:spChg>
+        <pc:spChg chg="del">
+          <ac:chgData name="Todd, Suzanne C  (DOH)" userId="af71578b-69d5-433a-9be5-dc8fe9528ab1" providerId="ADAL" clId="{F909BB2F-CC95-42AC-BCEF-9352AD515805}" dt="2023-07-29T23:10:10.113" v="977" actId="700"/>
+          <ac:spMkLst>
+            <pc:docMk/>
+            <pc:sldMk cId="2822355169" sldId="278"/>
+            <ac:spMk id="6" creationId="{39FA88DA-B2B7-CA51-A509-FA769C8376AE}"/>
+          </ac:spMkLst>
+        </pc:spChg>
+        <pc:spChg chg="del">
+          <ac:chgData name="Todd, Suzanne C  (DOH)" userId="af71578b-69d5-433a-9be5-dc8fe9528ab1" providerId="ADAL" clId="{F909BB2F-CC95-42AC-BCEF-9352AD515805}" dt="2023-07-29T23:10:10.113" v="977" actId="700"/>
+          <ac:spMkLst>
+            <pc:docMk/>
+            <pc:sldMk cId="2822355169" sldId="278"/>
+            <ac:spMk id="7" creationId="{1CBE6866-7672-91BB-B8C9-CBB0E0945724}"/>
+          </ac:spMkLst>
+        </pc:spChg>
+        <pc:spChg chg="del">
+          <ac:chgData name="Todd, Suzanne C  (DOH)" userId="af71578b-69d5-433a-9be5-dc8fe9528ab1" providerId="ADAL" clId="{F909BB2F-CC95-42AC-BCEF-9352AD515805}" dt="2023-07-29T23:10:10.113" v="977" actId="700"/>
+          <ac:spMkLst>
+            <pc:docMk/>
+            <pc:sldMk cId="2822355169" sldId="278"/>
+            <ac:spMk id="8" creationId="{5F816FC0-3D7E-6086-CA07-AF4B423F6C38}"/>
+          </ac:spMkLst>
+        </pc:spChg>
+        <pc:spChg chg="add mod ord">
+          <ac:chgData name="Todd, Suzanne C  (DOH)" userId="af71578b-69d5-433a-9be5-dc8fe9528ab1" providerId="ADAL" clId="{F909BB2F-CC95-42AC-BCEF-9352AD515805}" dt="2023-07-29T23:10:50.397" v="1037" actId="27636"/>
+          <ac:spMkLst>
+            <pc:docMk/>
+            <pc:sldMk cId="2822355169" sldId="278"/>
+            <ac:spMk id="9" creationId="{EDB82ECB-0A52-6114-416F-75499DF908AF}"/>
+          </ac:spMkLst>
+        </pc:spChg>
+        <pc:spChg chg="add mod ord">
+          <ac:chgData name="Todd, Suzanne C  (DOH)" userId="af71578b-69d5-433a-9be5-dc8fe9528ab1" providerId="ADAL" clId="{F909BB2F-CC95-42AC-BCEF-9352AD515805}" dt="2023-07-29T23:10:53.472" v="1038" actId="14100"/>
+          <ac:spMkLst>
+            <pc:docMk/>
+            <pc:sldMk cId="2822355169" sldId="278"/>
+            <ac:spMk id="10" creationId="{832E30FD-4200-7C98-8C42-4FA9CCF23744}"/>
+          </ac:spMkLst>
+        </pc:spChg>
+        <pc:graphicFrameChg chg="add mod modGraphic">
+          <ac:chgData name="Todd, Suzanne C  (DOH)" userId="af71578b-69d5-433a-9be5-dc8fe9528ab1" providerId="ADAL" clId="{F909BB2F-CC95-42AC-BCEF-9352AD515805}" dt="2023-07-29T23:18:32.065" v="1098" actId="20577"/>
+          <ac:graphicFrameMkLst>
+            <pc:docMk/>
+            <pc:sldMk cId="2822355169" sldId="278"/>
+            <ac:graphicFrameMk id="11" creationId="{1534F457-E41A-83D3-DBDE-E26408AE5667}"/>
+          </ac:graphicFrameMkLst>
+        </pc:graphicFrameChg>
       </pc:sldChg>
       <pc:sldChg chg="addSp delSp modSp new mod modClrScheme chgLayout">
         <pc:chgData name="Todd, Suzanne C  (DOH)" userId="af71578b-69d5-433a-9be5-dc8fe9528ab1" providerId="ADAL" clId="{F909BB2F-CC95-42AC-BCEF-9352AD515805}" dt="2023-07-29T23:23:25.403" v="1183" actId="14100"/>
@@ -267,6 +795,62 @@
           <pc:docMk/>
           <pc:sldMk cId="3557621340" sldId="279"/>
         </pc:sldMkLst>
+        <pc:spChg chg="add del mod ord">
+          <ac:chgData name="Todd, Suzanne C  (DOH)" userId="af71578b-69d5-433a-9be5-dc8fe9528ab1" providerId="ADAL" clId="{F909BB2F-CC95-42AC-BCEF-9352AD515805}" dt="2023-07-29T23:20:25.241" v="1128" actId="700"/>
+          <ac:spMkLst>
+            <pc:docMk/>
+            <pc:sldMk cId="3557621340" sldId="279"/>
+            <ac:spMk id="2" creationId="{C4334B32-83C9-349A-954E-B16333553821}"/>
+          </ac:spMkLst>
+        </pc:spChg>
+        <pc:spChg chg="add del">
+          <ac:chgData name="Todd, Suzanne C  (DOH)" userId="af71578b-69d5-433a-9be5-dc8fe9528ab1" providerId="ADAL" clId="{F909BB2F-CC95-42AC-BCEF-9352AD515805}" dt="2023-07-29T23:20:25.241" v="1128" actId="700"/>
+          <ac:spMkLst>
+            <pc:docMk/>
+            <pc:sldMk cId="3557621340" sldId="279"/>
+            <ac:spMk id="3" creationId="{9FF3869F-9BE8-23E1-A030-763EED0ABC6F}"/>
+          </ac:spMkLst>
+        </pc:spChg>
+        <pc:spChg chg="add del mod ord">
+          <ac:chgData name="Todd, Suzanne C  (DOH)" userId="af71578b-69d5-433a-9be5-dc8fe9528ab1" providerId="ADAL" clId="{F909BB2F-CC95-42AC-BCEF-9352AD515805}" dt="2023-07-29T23:20:25.241" v="1128" actId="700"/>
+          <ac:spMkLst>
+            <pc:docMk/>
+            <pc:sldMk cId="3557621340" sldId="279"/>
+            <ac:spMk id="4" creationId="{8C812F80-68E3-74F0-4A26-11A43D1C15E6}"/>
+          </ac:spMkLst>
+        </pc:spChg>
+        <pc:spChg chg="add del mod ord">
+          <ac:chgData name="Todd, Suzanne C  (DOH)" userId="af71578b-69d5-433a-9be5-dc8fe9528ab1" providerId="ADAL" clId="{F909BB2F-CC95-42AC-BCEF-9352AD515805}" dt="2023-07-29T23:20:20.802" v="1127" actId="700"/>
+          <ac:spMkLst>
+            <pc:docMk/>
+            <pc:sldMk cId="3557621340" sldId="279"/>
+            <ac:spMk id="5" creationId="{B1FAF80E-064A-1FCE-D907-159D7D141258}"/>
+          </ac:spMkLst>
+        </pc:spChg>
+        <pc:spChg chg="add mod ord">
+          <ac:chgData name="Todd, Suzanne C  (DOH)" userId="af71578b-69d5-433a-9be5-dc8fe9528ab1" providerId="ADAL" clId="{F909BB2F-CC95-42AC-BCEF-9352AD515805}" dt="2023-07-29T23:20:48.850" v="1167" actId="27636"/>
+          <ac:spMkLst>
+            <pc:docMk/>
+            <pc:sldMk cId="3557621340" sldId="279"/>
+            <ac:spMk id="6" creationId="{4400C858-E4A0-3168-DD71-2C7095D3C347}"/>
+          </ac:spMkLst>
+        </pc:spChg>
+        <pc:spChg chg="add mod ord">
+          <ac:chgData name="Todd, Suzanne C  (DOH)" userId="af71578b-69d5-433a-9be5-dc8fe9528ab1" providerId="ADAL" clId="{F909BB2F-CC95-42AC-BCEF-9352AD515805}" dt="2023-07-29T23:20:56.285" v="1169" actId="14100"/>
+          <ac:spMkLst>
+            <pc:docMk/>
+            <pc:sldMk cId="3557621340" sldId="279"/>
+            <ac:spMk id="7" creationId="{1D75F2B5-F2C3-CD7C-BF4F-D6027BDFDD66}"/>
+          </ac:spMkLst>
+        </pc:spChg>
+        <pc:graphicFrameChg chg="add mod modGraphic">
+          <ac:chgData name="Todd, Suzanne C  (DOH)" userId="af71578b-69d5-433a-9be5-dc8fe9528ab1" providerId="ADAL" clId="{F909BB2F-CC95-42AC-BCEF-9352AD515805}" dt="2023-07-29T23:23:25.403" v="1183" actId="14100"/>
+          <ac:graphicFrameMkLst>
+            <pc:docMk/>
+            <pc:sldMk cId="3557621340" sldId="279"/>
+            <ac:graphicFrameMk id="8" creationId="{CE7147AE-58F5-A6C7-4116-CB68AA679F05}"/>
+          </ac:graphicFrameMkLst>
+        </pc:graphicFrameChg>
       </pc:sldChg>
       <pc:sldChg chg="addSp modSp new mod">
         <pc:chgData name="Todd, Suzanne C  (DOH)" userId="af71578b-69d5-433a-9be5-dc8fe9528ab1" providerId="ADAL" clId="{F909BB2F-CC95-42AC-BCEF-9352AD515805}" dt="2023-07-29T23:32:50.268" v="1279" actId="20577"/>
@@ -274,6 +858,30 @@
           <pc:docMk/>
           <pc:sldMk cId="1115813720" sldId="280"/>
         </pc:sldMkLst>
+        <pc:spChg chg="mod">
+          <ac:chgData name="Todd, Suzanne C  (DOH)" userId="af71578b-69d5-433a-9be5-dc8fe9528ab1" providerId="ADAL" clId="{F909BB2F-CC95-42AC-BCEF-9352AD515805}" dt="2023-07-29T23:25:41.607" v="1205" actId="27636"/>
+          <ac:spMkLst>
+            <pc:docMk/>
+            <pc:sldMk cId="1115813720" sldId="280"/>
+            <ac:spMk id="2" creationId="{BD612446-0586-E676-3CA5-32D674B571D2}"/>
+          </ac:spMkLst>
+        </pc:spChg>
+        <pc:spChg chg="mod">
+          <ac:chgData name="Todd, Suzanne C  (DOH)" userId="af71578b-69d5-433a-9be5-dc8fe9528ab1" providerId="ADAL" clId="{F909BB2F-CC95-42AC-BCEF-9352AD515805}" dt="2023-07-29T23:29:34.686" v="1219" actId="6549"/>
+          <ac:spMkLst>
+            <pc:docMk/>
+            <pc:sldMk cId="1115813720" sldId="280"/>
+            <ac:spMk id="3" creationId="{41F97F09-D030-CA48-6661-EE56792100A9}"/>
+          </ac:spMkLst>
+        </pc:spChg>
+        <pc:graphicFrameChg chg="add mod modGraphic">
+          <ac:chgData name="Todd, Suzanne C  (DOH)" userId="af71578b-69d5-433a-9be5-dc8fe9528ab1" providerId="ADAL" clId="{F909BB2F-CC95-42AC-BCEF-9352AD515805}" dt="2023-07-29T23:32:50.268" v="1279" actId="20577"/>
+          <ac:graphicFrameMkLst>
+            <pc:docMk/>
+            <pc:sldMk cId="1115813720" sldId="280"/>
+            <ac:graphicFrameMk id="4" creationId="{E0524C8D-4896-9A8E-8C6C-6EBAFF65C1F3}"/>
+          </ac:graphicFrameMkLst>
+        </pc:graphicFrameChg>
       </pc:sldChg>
       <pc:sldChg chg="addSp delSp modSp new mod modClrScheme chgLayout">
         <pc:chgData name="Todd, Suzanne C  (DOH)" userId="af71578b-69d5-433a-9be5-dc8fe9528ab1" providerId="ADAL" clId="{F909BB2F-CC95-42AC-BCEF-9352AD515805}" dt="2023-07-30T00:04:29.847" v="1840" actId="13926"/>
@@ -281,6 +889,54 @@
           <pc:docMk/>
           <pc:sldMk cId="3283902001" sldId="281"/>
         </pc:sldMkLst>
+        <pc:spChg chg="del mod ord">
+          <ac:chgData name="Todd, Suzanne C  (DOH)" userId="af71578b-69d5-433a-9be5-dc8fe9528ab1" providerId="ADAL" clId="{F909BB2F-CC95-42AC-BCEF-9352AD515805}" dt="2023-07-29T23:38:40.642" v="1360" actId="700"/>
+          <ac:spMkLst>
+            <pc:docMk/>
+            <pc:sldMk cId="3283902001" sldId="281"/>
+            <ac:spMk id="2" creationId="{EED0E773-F2B8-8911-8CB0-0BAD85CD9AC7}"/>
+          </ac:spMkLst>
+        </pc:spChg>
+        <pc:spChg chg="del mod ord">
+          <ac:chgData name="Todd, Suzanne C  (DOH)" userId="af71578b-69d5-433a-9be5-dc8fe9528ab1" providerId="ADAL" clId="{F909BB2F-CC95-42AC-BCEF-9352AD515805}" dt="2023-07-29T23:38:40.642" v="1360" actId="700"/>
+          <ac:spMkLst>
+            <pc:docMk/>
+            <pc:sldMk cId="3283902001" sldId="281"/>
+            <ac:spMk id="3" creationId="{E4A7251E-58BE-1B36-B21C-6622A0591DAC}"/>
+          </ac:spMkLst>
+        </pc:spChg>
+        <pc:spChg chg="del">
+          <ac:chgData name="Todd, Suzanne C  (DOH)" userId="af71578b-69d5-433a-9be5-dc8fe9528ab1" providerId="ADAL" clId="{F909BB2F-CC95-42AC-BCEF-9352AD515805}" dt="2023-07-29T23:38:40.642" v="1360" actId="700"/>
+          <ac:spMkLst>
+            <pc:docMk/>
+            <pc:sldMk cId="3283902001" sldId="281"/>
+            <ac:spMk id="4" creationId="{1DF530C0-94E6-CE0F-98B6-64879E8D4EE2}"/>
+          </ac:spMkLst>
+        </pc:spChg>
+        <pc:spChg chg="add mod ord">
+          <ac:chgData name="Todd, Suzanne C  (DOH)" userId="af71578b-69d5-433a-9be5-dc8fe9528ab1" providerId="ADAL" clId="{F909BB2F-CC95-42AC-BCEF-9352AD515805}" dt="2023-07-29T23:39:57.138" v="1384" actId="313"/>
+          <ac:spMkLst>
+            <pc:docMk/>
+            <pc:sldMk cId="3283902001" sldId="281"/>
+            <ac:spMk id="5" creationId="{E836B4C9-D6BF-92D6-25CF-CC0D776E7275}"/>
+          </ac:spMkLst>
+        </pc:spChg>
+        <pc:spChg chg="add mod ord">
+          <ac:chgData name="Todd, Suzanne C  (DOH)" userId="af71578b-69d5-433a-9be5-dc8fe9528ab1" providerId="ADAL" clId="{F909BB2F-CC95-42AC-BCEF-9352AD515805}" dt="2023-07-29T23:40:08.380" v="1388" actId="6549"/>
+          <ac:spMkLst>
+            <pc:docMk/>
+            <pc:sldMk cId="3283902001" sldId="281"/>
+            <ac:spMk id="6" creationId="{19FE67ED-B925-CD88-8EEB-A43084C6AF5E}"/>
+          </ac:spMkLst>
+        </pc:spChg>
+        <pc:graphicFrameChg chg="add mod modGraphic">
+          <ac:chgData name="Todd, Suzanne C  (DOH)" userId="af71578b-69d5-433a-9be5-dc8fe9528ab1" providerId="ADAL" clId="{F909BB2F-CC95-42AC-BCEF-9352AD515805}" dt="2023-07-30T00:04:29.847" v="1840" actId="13926"/>
+          <ac:graphicFrameMkLst>
+            <pc:docMk/>
+            <pc:sldMk cId="3283902001" sldId="281"/>
+            <ac:graphicFrameMk id="7" creationId="{42A6B924-D150-8CC9-B2B4-4B8588B38AD7}"/>
+          </ac:graphicFrameMkLst>
+        </pc:graphicFrameChg>
       </pc:sldChg>
       <pc:sldChg chg="addSp delSp modSp new mod modClrScheme chgLayout">
         <pc:chgData name="Todd, Suzanne C  (DOH)" userId="af71578b-69d5-433a-9be5-dc8fe9528ab1" providerId="ADAL" clId="{F909BB2F-CC95-42AC-BCEF-9352AD515805}" dt="2023-07-29T23:56:20.048" v="1745" actId="20577"/>
@@ -288,6 +944,46 @@
           <pc:docMk/>
           <pc:sldMk cId="2202968588" sldId="282"/>
         </pc:sldMkLst>
+        <pc:spChg chg="del mod ord">
+          <ac:chgData name="Todd, Suzanne C  (DOH)" userId="af71578b-69d5-433a-9be5-dc8fe9528ab1" providerId="ADAL" clId="{F909BB2F-CC95-42AC-BCEF-9352AD515805}" dt="2023-07-29T23:51:40.277" v="1517" actId="700"/>
+          <ac:spMkLst>
+            <pc:docMk/>
+            <pc:sldMk cId="2202968588" sldId="282"/>
+            <ac:spMk id="2" creationId="{297F0A1E-D105-673A-C329-979465529BA1}"/>
+          </ac:spMkLst>
+        </pc:spChg>
+        <pc:spChg chg="del">
+          <ac:chgData name="Todd, Suzanne C  (DOH)" userId="af71578b-69d5-433a-9be5-dc8fe9528ab1" providerId="ADAL" clId="{F909BB2F-CC95-42AC-BCEF-9352AD515805}" dt="2023-07-29T23:51:40.277" v="1517" actId="700"/>
+          <ac:spMkLst>
+            <pc:docMk/>
+            <pc:sldMk cId="2202968588" sldId="282"/>
+            <ac:spMk id="3" creationId="{8A28327D-3624-C4EA-2A08-8A2DC5ED0873}"/>
+          </ac:spMkLst>
+        </pc:spChg>
+        <pc:spChg chg="del mod ord">
+          <ac:chgData name="Todd, Suzanne C  (DOH)" userId="af71578b-69d5-433a-9be5-dc8fe9528ab1" providerId="ADAL" clId="{F909BB2F-CC95-42AC-BCEF-9352AD515805}" dt="2023-07-29T23:51:40.277" v="1517" actId="700"/>
+          <ac:spMkLst>
+            <pc:docMk/>
+            <pc:sldMk cId="2202968588" sldId="282"/>
+            <ac:spMk id="4" creationId="{E13C663F-9060-544A-7E3B-E97CAD488B5E}"/>
+          </ac:spMkLst>
+        </pc:spChg>
+        <pc:spChg chg="add mod ord">
+          <ac:chgData name="Todd, Suzanne C  (DOH)" userId="af71578b-69d5-433a-9be5-dc8fe9528ab1" providerId="ADAL" clId="{F909BB2F-CC95-42AC-BCEF-9352AD515805}" dt="2023-07-29T23:52:00.621" v="1528" actId="14100"/>
+          <ac:spMkLst>
+            <pc:docMk/>
+            <pc:sldMk cId="2202968588" sldId="282"/>
+            <ac:spMk id="5" creationId="{289D6052-EA05-1F03-74E5-8629DEC3B44F}"/>
+          </ac:spMkLst>
+        </pc:spChg>
+        <pc:spChg chg="add mod ord">
+          <ac:chgData name="Todd, Suzanne C  (DOH)" userId="af71578b-69d5-433a-9be5-dc8fe9528ab1" providerId="ADAL" clId="{F909BB2F-CC95-42AC-BCEF-9352AD515805}" dt="2023-07-29T23:56:20.048" v="1745" actId="20577"/>
+          <ac:spMkLst>
+            <pc:docMk/>
+            <pc:sldMk cId="2202968588" sldId="282"/>
+            <ac:spMk id="6" creationId="{E16383AE-DE99-7D69-A61E-6F077561CA77}"/>
+          </ac:spMkLst>
+        </pc:spChg>
       </pc:sldChg>
       <pc:sldChg chg="addSp delSp modSp new mod modClrScheme chgLayout">
         <pc:chgData name="Todd, Suzanne C  (DOH)" userId="af71578b-69d5-433a-9be5-dc8fe9528ab1" providerId="ADAL" clId="{F909BB2F-CC95-42AC-BCEF-9352AD515805}" dt="2023-07-29T23:57:19.801" v="1825" actId="20577"/>
@@ -295,16 +991,39 @@
           <pc:docMk/>
           <pc:sldMk cId="3360323603" sldId="283"/>
         </pc:sldMkLst>
+        <pc:spChg chg="del mod ord">
+          <ac:chgData name="Todd, Suzanne C  (DOH)" userId="af71578b-69d5-433a-9be5-dc8fe9528ab1" providerId="ADAL" clId="{F909BB2F-CC95-42AC-BCEF-9352AD515805}" dt="2023-07-29T23:56:29.717" v="1746" actId="700"/>
+          <ac:spMkLst>
+            <pc:docMk/>
+            <pc:sldMk cId="3360323603" sldId="283"/>
+            <ac:spMk id="2" creationId="{EDCAF14F-FC86-9D8F-76E8-BEBF2CB9F4F3}"/>
+          </ac:spMkLst>
+        </pc:spChg>
+        <pc:spChg chg="del">
+          <ac:chgData name="Todd, Suzanne C  (DOH)" userId="af71578b-69d5-433a-9be5-dc8fe9528ab1" providerId="ADAL" clId="{F909BB2F-CC95-42AC-BCEF-9352AD515805}" dt="2023-07-29T23:56:29.717" v="1746" actId="700"/>
+          <ac:spMkLst>
+            <pc:docMk/>
+            <pc:sldMk cId="3360323603" sldId="283"/>
+            <ac:spMk id="3" creationId="{3A302A1A-501C-FD4D-94A6-7E74570CB5E8}"/>
+          </ac:spMkLst>
+        </pc:spChg>
+        <pc:spChg chg="del">
+          <ac:chgData name="Todd, Suzanne C  (DOH)" userId="af71578b-69d5-433a-9be5-dc8fe9528ab1" providerId="ADAL" clId="{F909BB2F-CC95-42AC-BCEF-9352AD515805}" dt="2023-07-29T23:56:29.717" v="1746" actId="700"/>
+          <ac:spMkLst>
+            <pc:docMk/>
+            <pc:sldMk cId="3360323603" sldId="283"/>
+            <ac:spMk id="4" creationId="{CFB12031-82A7-3627-640A-99F2A452308B}"/>
+          </ac:spMkLst>
+        </pc:spChg>
+        <pc:spChg chg="add mod ord">
+          <ac:chgData name="Todd, Suzanne C  (DOH)" userId="af71578b-69d5-433a-9be5-dc8fe9528ab1" providerId="ADAL" clId="{F909BB2F-CC95-42AC-BCEF-9352AD515805}" dt="2023-07-29T23:57:19.801" v="1825" actId="20577"/>
+          <ac:spMkLst>
+            <pc:docMk/>
+            <pc:sldMk cId="3360323603" sldId="283"/>
+            <ac:spMk id="5" creationId="{1FA3AFFC-FE3B-5A1B-EA07-724A317B203A}"/>
+          </ac:spMkLst>
+        </pc:spChg>
       </pc:sldChg>
-    </pc:docChg>
-  </pc:docChgLst>
-  <pc:docChgLst>
-    <pc:chgData name="Milligan, Jane D (DOH)" userId="S::jane.milligan@doh.wa.gov::06d24e7d-2e4f-475e-b4ff-724e8bd74288" providerId="AD" clId="Web-{DCC8CE56-CDC1-2B05-0667-B4E156BBCBFF}"/>
-    <pc:docChg chg="mod">
-      <pc:chgData name="Milligan, Jane D (DOH)" userId="S::jane.milligan@doh.wa.gov::06d24e7d-2e4f-475e-b4ff-724e8bd74288" providerId="AD" clId="Web-{DCC8CE56-CDC1-2B05-0667-B4E156BBCBFF}" dt="2025-03-05T19:18:15.899" v="0" actId="33475"/>
-      <pc:docMkLst>
-        <pc:docMk/>
-      </pc:docMkLst>
     </pc:docChg>
   </pc:docChgLst>
   <pc:docChgLst>
@@ -320,6 +1039,14 @@
           <pc:docMk/>
           <pc:sldMk cId="234459859" sldId="260"/>
         </pc:sldMkLst>
+        <pc:spChg chg="mod">
+          <ac:chgData name="Kuykendall, Jon  (DOH)" userId="d913a90c-1e09-43d3-802c-6017c2088196" providerId="ADAL" clId="{22D6D971-81A8-444C-9D91-5577FA95D32F}" dt="2023-07-31T21:25:26.458" v="51" actId="20577"/>
+          <ac:spMkLst>
+            <pc:docMk/>
+            <pc:sldMk cId="234459859" sldId="260"/>
+            <ac:spMk id="4" creationId="{00000000-0000-0000-0000-000000000000}"/>
+          </ac:spMkLst>
+        </pc:spChg>
       </pc:sldChg>
       <pc:sldChg chg="modSp mod">
         <pc:chgData name="Kuykendall, Jon  (DOH)" userId="d913a90c-1e09-43d3-802c-6017c2088196" providerId="ADAL" clId="{22D6D971-81A8-444C-9D91-5577FA95D32F}" dt="2023-07-31T21:30:29.387" v="139" actId="20577"/>
@@ -327,6 +1054,14 @@
           <pc:docMk/>
           <pc:sldMk cId="3663717395" sldId="261"/>
         </pc:sldMkLst>
+        <pc:spChg chg="mod">
+          <ac:chgData name="Kuykendall, Jon  (DOH)" userId="d913a90c-1e09-43d3-802c-6017c2088196" providerId="ADAL" clId="{22D6D971-81A8-444C-9D91-5577FA95D32F}" dt="2023-07-31T21:30:29.387" v="139" actId="20577"/>
+          <ac:spMkLst>
+            <pc:docMk/>
+            <pc:sldMk cId="3663717395" sldId="261"/>
+            <ac:spMk id="4" creationId="{00000000-0000-0000-0000-000000000000}"/>
+          </ac:spMkLst>
+        </pc:spChg>
       </pc:sldChg>
       <pc:sldChg chg="modSp mod">
         <pc:chgData name="Kuykendall, Jon  (DOH)" userId="d913a90c-1e09-43d3-802c-6017c2088196" providerId="ADAL" clId="{22D6D971-81A8-444C-9D91-5577FA95D32F}" dt="2023-07-31T21:35:05.699" v="383" actId="20577"/>
@@ -334,6 +1069,14 @@
           <pc:docMk/>
           <pc:sldMk cId="3332275302" sldId="262"/>
         </pc:sldMkLst>
+        <pc:spChg chg="mod">
+          <ac:chgData name="Kuykendall, Jon  (DOH)" userId="d913a90c-1e09-43d3-802c-6017c2088196" providerId="ADAL" clId="{22D6D971-81A8-444C-9D91-5577FA95D32F}" dt="2023-07-31T21:35:05.699" v="383" actId="20577"/>
+          <ac:spMkLst>
+            <pc:docMk/>
+            <pc:sldMk cId="3332275302" sldId="262"/>
+            <ac:spMk id="4" creationId="{00000000-0000-0000-0000-000000000000}"/>
+          </ac:spMkLst>
+        </pc:spChg>
       </pc:sldChg>
       <pc:sldChg chg="modSp mod">
         <pc:chgData name="Kuykendall, Jon  (DOH)" userId="d913a90c-1e09-43d3-802c-6017c2088196" providerId="ADAL" clId="{22D6D971-81A8-444C-9D91-5577FA95D32F}" dt="2023-07-31T21:49:34.147" v="583" actId="20577"/>
@@ -341,6 +1084,14 @@
           <pc:docMk/>
           <pc:sldMk cId="3625022557" sldId="264"/>
         </pc:sldMkLst>
+        <pc:spChg chg="mod">
+          <ac:chgData name="Kuykendall, Jon  (DOH)" userId="d913a90c-1e09-43d3-802c-6017c2088196" providerId="ADAL" clId="{22D6D971-81A8-444C-9D91-5577FA95D32F}" dt="2023-07-31T21:49:34.147" v="583" actId="20577"/>
+          <ac:spMkLst>
+            <pc:docMk/>
+            <pc:sldMk cId="3625022557" sldId="264"/>
+            <ac:spMk id="8" creationId="{00000000-0000-0000-0000-000000000000}"/>
+          </ac:spMkLst>
+        </pc:spChg>
       </pc:sldChg>
       <pc:sldChg chg="modSp mod">
         <pc:chgData name="Kuykendall, Jon  (DOH)" userId="d913a90c-1e09-43d3-802c-6017c2088196" providerId="ADAL" clId="{22D6D971-81A8-444C-9D91-5577FA95D32F}" dt="2023-07-31T22:05:13.288" v="872" actId="20577"/>
@@ -348,6 +1099,14 @@
           <pc:docMk/>
           <pc:sldMk cId="2983800514" sldId="266"/>
         </pc:sldMkLst>
+        <pc:spChg chg="mod">
+          <ac:chgData name="Kuykendall, Jon  (DOH)" userId="d913a90c-1e09-43d3-802c-6017c2088196" providerId="ADAL" clId="{22D6D971-81A8-444C-9D91-5577FA95D32F}" dt="2023-07-31T22:05:13.288" v="872" actId="20577"/>
+          <ac:spMkLst>
+            <pc:docMk/>
+            <pc:sldMk cId="2983800514" sldId="266"/>
+            <ac:spMk id="3" creationId="{00000000-0000-0000-0000-000000000000}"/>
+          </ac:spMkLst>
+        </pc:spChg>
       </pc:sldChg>
       <pc:sldChg chg="modSp mod">
         <pc:chgData name="Kuykendall, Jon  (DOH)" userId="d913a90c-1e09-43d3-802c-6017c2088196" providerId="ADAL" clId="{22D6D971-81A8-444C-9D91-5577FA95D32F}" dt="2023-07-31T22:08:22.015" v="929" actId="1076"/>
@@ -355,6 +1114,30 @@
           <pc:docMk/>
           <pc:sldMk cId="4084762284" sldId="267"/>
         </pc:sldMkLst>
+        <pc:spChg chg="mod">
+          <ac:chgData name="Kuykendall, Jon  (DOH)" userId="d913a90c-1e09-43d3-802c-6017c2088196" providerId="ADAL" clId="{22D6D971-81A8-444C-9D91-5577FA95D32F}" dt="2023-07-31T22:07:31.211" v="893" actId="20577"/>
+          <ac:spMkLst>
+            <pc:docMk/>
+            <pc:sldMk cId="4084762284" sldId="267"/>
+            <ac:spMk id="2" creationId="{00000000-0000-0000-0000-000000000000}"/>
+          </ac:spMkLst>
+        </pc:spChg>
+        <pc:spChg chg="mod">
+          <ac:chgData name="Kuykendall, Jon  (DOH)" userId="d913a90c-1e09-43d3-802c-6017c2088196" providerId="ADAL" clId="{22D6D971-81A8-444C-9D91-5577FA95D32F}" dt="2023-07-31T22:08:19.562" v="928" actId="1076"/>
+          <ac:spMkLst>
+            <pc:docMk/>
+            <pc:sldMk cId="4084762284" sldId="267"/>
+            <ac:spMk id="3" creationId="{00000000-0000-0000-0000-000000000000}"/>
+          </ac:spMkLst>
+        </pc:spChg>
+        <pc:picChg chg="mod">
+          <ac:chgData name="Kuykendall, Jon  (DOH)" userId="d913a90c-1e09-43d3-802c-6017c2088196" providerId="ADAL" clId="{22D6D971-81A8-444C-9D91-5577FA95D32F}" dt="2023-07-31T22:08:22.015" v="929" actId="1076"/>
+          <ac:picMkLst>
+            <pc:docMk/>
+            <pc:sldMk cId="4084762284" sldId="267"/>
+            <ac:picMk id="5" creationId="{00000000-0000-0000-0000-000000000000}"/>
+          </ac:picMkLst>
+        </pc:picChg>
       </pc:sldChg>
       <pc:sldChg chg="modSp mod">
         <pc:chgData name="Kuykendall, Jon  (DOH)" userId="d913a90c-1e09-43d3-802c-6017c2088196" providerId="ADAL" clId="{22D6D971-81A8-444C-9D91-5577FA95D32F}" dt="2023-07-31T22:11:57.376" v="948" actId="13926"/>
@@ -362,6 +1145,14 @@
           <pc:docMk/>
           <pc:sldMk cId="1368993529" sldId="268"/>
         </pc:sldMkLst>
+        <pc:spChg chg="mod">
+          <ac:chgData name="Kuykendall, Jon  (DOH)" userId="d913a90c-1e09-43d3-802c-6017c2088196" providerId="ADAL" clId="{22D6D971-81A8-444C-9D91-5577FA95D32F}" dt="2023-07-31T22:11:57.376" v="948" actId="13926"/>
+          <ac:spMkLst>
+            <pc:docMk/>
+            <pc:sldMk cId="1368993529" sldId="268"/>
+            <ac:spMk id="4" creationId="{00000000-0000-0000-0000-000000000000}"/>
+          </ac:spMkLst>
+        </pc:spChg>
       </pc:sldChg>
       <pc:sldChg chg="addSp delSp modSp mod">
         <pc:chgData name="Kuykendall, Jon  (DOH)" userId="d913a90c-1e09-43d3-802c-6017c2088196" providerId="ADAL" clId="{22D6D971-81A8-444C-9D91-5577FA95D32F}" dt="2023-07-31T22:14:45.740" v="1093" actId="115"/>
@@ -369,6 +1160,38 @@
           <pc:docMk/>
           <pc:sldMk cId="3071771991" sldId="271"/>
         </pc:sldMkLst>
+        <pc:spChg chg="mod">
+          <ac:chgData name="Kuykendall, Jon  (DOH)" userId="d913a90c-1e09-43d3-802c-6017c2088196" providerId="ADAL" clId="{22D6D971-81A8-444C-9D91-5577FA95D32F}" dt="2023-07-31T22:14:45.740" v="1093" actId="115"/>
+          <ac:spMkLst>
+            <pc:docMk/>
+            <pc:sldMk cId="3071771991" sldId="271"/>
+            <ac:spMk id="2" creationId="{00000000-0000-0000-0000-000000000000}"/>
+          </ac:spMkLst>
+        </pc:spChg>
+        <pc:spChg chg="mod">
+          <ac:chgData name="Kuykendall, Jon  (DOH)" userId="d913a90c-1e09-43d3-802c-6017c2088196" providerId="ADAL" clId="{22D6D971-81A8-444C-9D91-5577FA95D32F}" dt="2023-07-31T22:14:37.795" v="1092" actId="1076"/>
+          <ac:spMkLst>
+            <pc:docMk/>
+            <pc:sldMk cId="3071771991" sldId="271"/>
+            <ac:spMk id="3" creationId="{00000000-0000-0000-0000-000000000000}"/>
+          </ac:spMkLst>
+        </pc:spChg>
+        <pc:spChg chg="del mod">
+          <ac:chgData name="Kuykendall, Jon  (DOH)" userId="d913a90c-1e09-43d3-802c-6017c2088196" providerId="ADAL" clId="{22D6D971-81A8-444C-9D91-5577FA95D32F}" dt="2023-07-31T22:14:26.878" v="1090" actId="21"/>
+          <ac:spMkLst>
+            <pc:docMk/>
+            <pc:sldMk cId="3071771991" sldId="271"/>
+            <ac:spMk id="4" creationId="{00000000-0000-0000-0000-000000000000}"/>
+          </ac:spMkLst>
+        </pc:spChg>
+        <pc:spChg chg="add del mod">
+          <ac:chgData name="Kuykendall, Jon  (DOH)" userId="d913a90c-1e09-43d3-802c-6017c2088196" providerId="ADAL" clId="{22D6D971-81A8-444C-9D91-5577FA95D32F}" dt="2023-07-31T22:14:32.228" v="1091" actId="21"/>
+          <ac:spMkLst>
+            <pc:docMk/>
+            <pc:sldMk cId="3071771991" sldId="271"/>
+            <ac:spMk id="6" creationId="{C98C6EA5-E05E-0CD9-3D07-24D69937ACAF}"/>
+          </ac:spMkLst>
+        </pc:spChg>
       </pc:sldChg>
       <pc:sldChg chg="modSp mod">
         <pc:chgData name="Kuykendall, Jon  (DOH)" userId="d913a90c-1e09-43d3-802c-6017c2088196" providerId="ADAL" clId="{22D6D971-81A8-444C-9D91-5577FA95D32F}" dt="2023-07-31T22:16:07.107" v="1098" actId="20577"/>
@@ -376,6 +1199,14 @@
           <pc:docMk/>
           <pc:sldMk cId="1064846061" sldId="272"/>
         </pc:sldMkLst>
+        <pc:spChg chg="mod">
+          <ac:chgData name="Kuykendall, Jon  (DOH)" userId="d913a90c-1e09-43d3-802c-6017c2088196" providerId="ADAL" clId="{22D6D971-81A8-444C-9D91-5577FA95D32F}" dt="2023-07-31T22:16:07.107" v="1098" actId="20577"/>
+          <ac:spMkLst>
+            <pc:docMk/>
+            <pc:sldMk cId="1064846061" sldId="272"/>
+            <ac:spMk id="4" creationId="{00000000-0000-0000-0000-000000000000}"/>
+          </ac:spMkLst>
+        </pc:spChg>
       </pc:sldChg>
       <pc:sldChg chg="modSp mod">
         <pc:chgData name="Kuykendall, Jon  (DOH)" userId="d913a90c-1e09-43d3-802c-6017c2088196" providerId="ADAL" clId="{22D6D971-81A8-444C-9D91-5577FA95D32F}" dt="2023-07-31T21:29:02.848" v="54" actId="13926"/>
@@ -383,6 +1214,22 @@
           <pc:docMk/>
           <pc:sldMk cId="1748972345" sldId="274"/>
         </pc:sldMkLst>
+        <pc:graphicFrameChg chg="modGraphic">
+          <ac:chgData name="Kuykendall, Jon  (DOH)" userId="d913a90c-1e09-43d3-802c-6017c2088196" providerId="ADAL" clId="{22D6D971-81A8-444C-9D91-5577FA95D32F}" dt="2023-07-31T21:28:54.976" v="53" actId="13926"/>
+          <ac:graphicFrameMkLst>
+            <pc:docMk/>
+            <pc:sldMk cId="1748972345" sldId="274"/>
+            <ac:graphicFrameMk id="10" creationId="{CA94B255-E25B-1F1C-9148-8E4D3805DD9B}"/>
+          </ac:graphicFrameMkLst>
+        </pc:graphicFrameChg>
+        <pc:graphicFrameChg chg="modGraphic">
+          <ac:chgData name="Kuykendall, Jon  (DOH)" userId="d913a90c-1e09-43d3-802c-6017c2088196" providerId="ADAL" clId="{22D6D971-81A8-444C-9D91-5577FA95D32F}" dt="2023-07-31T21:29:02.848" v="54" actId="13926"/>
+          <ac:graphicFrameMkLst>
+            <pc:docMk/>
+            <pc:sldMk cId="1748972345" sldId="274"/>
+            <ac:graphicFrameMk id="11" creationId="{ECDBD5A8-0E72-13A6-E80C-3E26FE5A6810}"/>
+          </ac:graphicFrameMkLst>
+        </pc:graphicFrameChg>
       </pc:sldChg>
       <pc:sldChg chg="modSp mod">
         <pc:chgData name="Kuykendall, Jon  (DOH)" userId="d913a90c-1e09-43d3-802c-6017c2088196" providerId="ADAL" clId="{22D6D971-81A8-444C-9D91-5577FA95D32F}" dt="2023-07-31T21:34:07.666" v="381" actId="20577"/>
@@ -390,6 +1237,30 @@
           <pc:docMk/>
           <pc:sldMk cId="1238034687" sldId="276"/>
         </pc:sldMkLst>
+        <pc:spChg chg="mod">
+          <ac:chgData name="Kuykendall, Jon  (DOH)" userId="d913a90c-1e09-43d3-802c-6017c2088196" providerId="ADAL" clId="{22D6D971-81A8-444C-9D91-5577FA95D32F}" dt="2023-07-31T21:31:09.929" v="143" actId="20577"/>
+          <ac:spMkLst>
+            <pc:docMk/>
+            <pc:sldMk cId="1238034687" sldId="276"/>
+            <ac:spMk id="5" creationId="{D8DF5E9A-5780-E496-5ACB-EF16EC2F4C16}"/>
+          </ac:spMkLst>
+        </pc:spChg>
+        <pc:graphicFrameChg chg="modGraphic">
+          <ac:chgData name="Kuykendall, Jon  (DOH)" userId="d913a90c-1e09-43d3-802c-6017c2088196" providerId="ADAL" clId="{22D6D971-81A8-444C-9D91-5577FA95D32F}" dt="2023-07-31T21:33:07.285" v="256" actId="13926"/>
+          <ac:graphicFrameMkLst>
+            <pc:docMk/>
+            <pc:sldMk cId="1238034687" sldId="276"/>
+            <ac:graphicFrameMk id="10" creationId="{CA94B255-E25B-1F1C-9148-8E4D3805DD9B}"/>
+          </ac:graphicFrameMkLst>
+        </pc:graphicFrameChg>
+        <pc:graphicFrameChg chg="modGraphic">
+          <ac:chgData name="Kuykendall, Jon  (DOH)" userId="d913a90c-1e09-43d3-802c-6017c2088196" providerId="ADAL" clId="{22D6D971-81A8-444C-9D91-5577FA95D32F}" dt="2023-07-31T21:34:07.666" v="381" actId="20577"/>
+          <ac:graphicFrameMkLst>
+            <pc:docMk/>
+            <pc:sldMk cId="1238034687" sldId="276"/>
+            <ac:graphicFrameMk id="11" creationId="{ECDBD5A8-0E72-13A6-E80C-3E26FE5A6810}"/>
+          </ac:graphicFrameMkLst>
+        </pc:graphicFrameChg>
       </pc:sldChg>
       <pc:sldChg chg="modSp mod">
         <pc:chgData name="Kuykendall, Jon  (DOH)" userId="d913a90c-1e09-43d3-802c-6017c2088196" providerId="ADAL" clId="{22D6D971-81A8-444C-9D91-5577FA95D32F}" dt="2023-07-31T21:37:07.996" v="397" actId="113"/>
@@ -397,6 +1268,14 @@
           <pc:docMk/>
           <pc:sldMk cId="2509298696" sldId="277"/>
         </pc:sldMkLst>
+        <pc:spChg chg="mod">
+          <ac:chgData name="Kuykendall, Jon  (DOH)" userId="d913a90c-1e09-43d3-802c-6017c2088196" providerId="ADAL" clId="{22D6D971-81A8-444C-9D91-5577FA95D32F}" dt="2023-07-31T21:37:07.996" v="397" actId="113"/>
+          <ac:spMkLst>
+            <pc:docMk/>
+            <pc:sldMk cId="2509298696" sldId="277"/>
+            <ac:spMk id="6" creationId="{2470B95B-9355-2C18-87DD-DD9AACEEABBD}"/>
+          </ac:spMkLst>
+        </pc:spChg>
       </pc:sldChg>
       <pc:sldChg chg="addSp delSp modSp del mod">
         <pc:chgData name="Kuykendall, Jon  (DOH)" userId="d913a90c-1e09-43d3-802c-6017c2088196" providerId="ADAL" clId="{22D6D971-81A8-444C-9D91-5577FA95D32F}" dt="2023-07-31T21:46:05.660" v="525" actId="2696"/>
@@ -404,6 +1283,30 @@
           <pc:docMk/>
           <pc:sldMk cId="2822355169" sldId="278"/>
         </pc:sldMkLst>
+        <pc:spChg chg="add del mod">
+          <ac:chgData name="Kuykendall, Jon  (DOH)" userId="d913a90c-1e09-43d3-802c-6017c2088196" providerId="ADAL" clId="{22D6D971-81A8-444C-9D91-5577FA95D32F}" dt="2023-07-31T21:44:11.943" v="499" actId="21"/>
+          <ac:spMkLst>
+            <pc:docMk/>
+            <pc:sldMk cId="2822355169" sldId="278"/>
+            <ac:spMk id="3" creationId="{6337E2E9-DF03-AF7D-74C7-611398106DA2}"/>
+          </ac:spMkLst>
+        </pc:spChg>
+        <pc:spChg chg="add del mod">
+          <ac:chgData name="Kuykendall, Jon  (DOH)" userId="d913a90c-1e09-43d3-802c-6017c2088196" providerId="ADAL" clId="{22D6D971-81A8-444C-9D91-5577FA95D32F}" dt="2023-07-31T21:43:24.641" v="487" actId="21"/>
+          <ac:spMkLst>
+            <pc:docMk/>
+            <pc:sldMk cId="2822355169" sldId="278"/>
+            <ac:spMk id="10" creationId="{832E30FD-4200-7C98-8C42-4FA9CCF23744}"/>
+          </ac:spMkLst>
+        </pc:spChg>
+        <pc:graphicFrameChg chg="mod modGraphic">
+          <ac:chgData name="Kuykendall, Jon  (DOH)" userId="d913a90c-1e09-43d3-802c-6017c2088196" providerId="ADAL" clId="{22D6D971-81A8-444C-9D91-5577FA95D32F}" dt="2023-07-31T21:46:01.439" v="524" actId="14734"/>
+          <ac:graphicFrameMkLst>
+            <pc:docMk/>
+            <pc:sldMk cId="2822355169" sldId="278"/>
+            <ac:graphicFrameMk id="11" creationId="{1534F457-E41A-83D3-DBDE-E26408AE5667}"/>
+          </ac:graphicFrameMkLst>
+        </pc:graphicFrameChg>
       </pc:sldChg>
       <pc:sldChg chg="delSp modSp mod">
         <pc:chgData name="Kuykendall, Jon  (DOH)" userId="d913a90c-1e09-43d3-802c-6017c2088196" providerId="ADAL" clId="{22D6D971-81A8-444C-9D91-5577FA95D32F}" dt="2023-07-31T21:52:51.880" v="588" actId="21"/>
@@ -411,6 +1314,22 @@
           <pc:docMk/>
           <pc:sldMk cId="3557621340" sldId="279"/>
         </pc:sldMkLst>
+        <pc:spChg chg="del">
+          <ac:chgData name="Kuykendall, Jon  (DOH)" userId="d913a90c-1e09-43d3-802c-6017c2088196" providerId="ADAL" clId="{22D6D971-81A8-444C-9D91-5577FA95D32F}" dt="2023-07-31T21:52:51.880" v="588" actId="21"/>
+          <ac:spMkLst>
+            <pc:docMk/>
+            <pc:sldMk cId="3557621340" sldId="279"/>
+            <ac:spMk id="7" creationId="{1D75F2B5-F2C3-CD7C-BF4F-D6027BDFDD66}"/>
+          </ac:spMkLst>
+        </pc:spChg>
+        <pc:graphicFrameChg chg="mod">
+          <ac:chgData name="Kuykendall, Jon  (DOH)" userId="d913a90c-1e09-43d3-802c-6017c2088196" providerId="ADAL" clId="{22D6D971-81A8-444C-9D91-5577FA95D32F}" dt="2023-07-31T21:52:30.714" v="587" actId="1076"/>
+          <ac:graphicFrameMkLst>
+            <pc:docMk/>
+            <pc:sldMk cId="3557621340" sldId="279"/>
+            <ac:graphicFrameMk id="8" creationId="{CE7147AE-58F5-A6C7-4116-CB68AA679F05}"/>
+          </ac:graphicFrameMkLst>
+        </pc:graphicFrameChg>
       </pc:sldChg>
       <pc:sldChg chg="modSp mod">
         <pc:chgData name="Kuykendall, Jon  (DOH)" userId="d913a90c-1e09-43d3-802c-6017c2088196" providerId="ADAL" clId="{22D6D971-81A8-444C-9D91-5577FA95D32F}" dt="2023-07-31T22:06:56.434" v="884" actId="20577"/>
@@ -418,6 +1337,14 @@
           <pc:docMk/>
           <pc:sldMk cId="1115813720" sldId="280"/>
         </pc:sldMkLst>
+        <pc:graphicFrameChg chg="modGraphic">
+          <ac:chgData name="Kuykendall, Jon  (DOH)" userId="d913a90c-1e09-43d3-802c-6017c2088196" providerId="ADAL" clId="{22D6D971-81A8-444C-9D91-5577FA95D32F}" dt="2023-07-31T22:06:56.434" v="884" actId="20577"/>
+          <ac:graphicFrameMkLst>
+            <pc:docMk/>
+            <pc:sldMk cId="1115813720" sldId="280"/>
+            <ac:graphicFrameMk id="4" creationId="{E0524C8D-4896-9A8E-8C6C-6EBAFF65C1F3}"/>
+          </ac:graphicFrameMkLst>
+        </pc:graphicFrameChg>
       </pc:sldChg>
       <pc:sldChg chg="modSp mod">
         <pc:chgData name="Kuykendall, Jon  (DOH)" userId="d913a90c-1e09-43d3-802c-6017c2088196" providerId="ADAL" clId="{22D6D971-81A8-444C-9D91-5577FA95D32F}" dt="2023-07-31T22:09:47.234" v="935" actId="13926"/>
@@ -425,6 +1352,22 @@
           <pc:docMk/>
           <pc:sldMk cId="3283902001" sldId="281"/>
         </pc:sldMkLst>
+        <pc:spChg chg="mod">
+          <ac:chgData name="Kuykendall, Jon  (DOH)" userId="d913a90c-1e09-43d3-802c-6017c2088196" providerId="ADAL" clId="{22D6D971-81A8-444C-9D91-5577FA95D32F}" dt="2023-07-31T22:08:30.064" v="930" actId="1076"/>
+          <ac:spMkLst>
+            <pc:docMk/>
+            <pc:sldMk cId="3283902001" sldId="281"/>
+            <ac:spMk id="5" creationId="{E836B4C9-D6BF-92D6-25CF-CC0D776E7275}"/>
+          </ac:spMkLst>
+        </pc:spChg>
+        <pc:graphicFrameChg chg="modGraphic">
+          <ac:chgData name="Kuykendall, Jon  (DOH)" userId="d913a90c-1e09-43d3-802c-6017c2088196" providerId="ADAL" clId="{22D6D971-81A8-444C-9D91-5577FA95D32F}" dt="2023-07-31T22:09:47.234" v="935" actId="13926"/>
+          <ac:graphicFrameMkLst>
+            <pc:docMk/>
+            <pc:sldMk cId="3283902001" sldId="281"/>
+            <ac:graphicFrameMk id="7" creationId="{42A6B924-D150-8CC9-B2B4-4B8588B38AD7}"/>
+          </ac:graphicFrameMkLst>
+        </pc:graphicFrameChg>
       </pc:sldChg>
       <pc:sldChg chg="modSp mod">
         <pc:chgData name="Kuykendall, Jon  (DOH)" userId="d913a90c-1e09-43d3-802c-6017c2088196" providerId="ADAL" clId="{22D6D971-81A8-444C-9D91-5577FA95D32F}" dt="2023-07-31T22:17:35.039" v="1131" actId="14100"/>
@@ -432,6 +1375,22 @@
           <pc:docMk/>
           <pc:sldMk cId="2202968588" sldId="282"/>
         </pc:sldMkLst>
+        <pc:spChg chg="mod">
+          <ac:chgData name="Kuykendall, Jon  (DOH)" userId="d913a90c-1e09-43d3-802c-6017c2088196" providerId="ADAL" clId="{22D6D971-81A8-444C-9D91-5577FA95D32F}" dt="2023-07-31T22:16:56.810" v="1101" actId="115"/>
+          <ac:spMkLst>
+            <pc:docMk/>
+            <pc:sldMk cId="2202968588" sldId="282"/>
+            <ac:spMk id="5" creationId="{289D6052-EA05-1F03-74E5-8629DEC3B44F}"/>
+          </ac:spMkLst>
+        </pc:spChg>
+        <pc:spChg chg="mod">
+          <ac:chgData name="Kuykendall, Jon  (DOH)" userId="d913a90c-1e09-43d3-802c-6017c2088196" providerId="ADAL" clId="{22D6D971-81A8-444C-9D91-5577FA95D32F}" dt="2023-07-31T22:17:35.039" v="1131" actId="14100"/>
+          <ac:spMkLst>
+            <pc:docMk/>
+            <pc:sldMk cId="2202968588" sldId="282"/>
+            <ac:spMk id="6" creationId="{E16383AE-DE99-7D69-A61E-6F077561CA77}"/>
+          </ac:spMkLst>
+        </pc:spChg>
       </pc:sldChg>
       <pc:sldChg chg="addSp delSp modSp mod setBg addAnim">
         <pc:chgData name="Kuykendall, Jon  (DOH)" userId="d913a90c-1e09-43d3-802c-6017c2088196" providerId="ADAL" clId="{22D6D971-81A8-444C-9D91-5577FA95D32F}" dt="2023-07-31T22:20:41.653" v="1150" actId="1076"/>
@@ -439,6 +1398,110 @@
           <pc:docMk/>
           <pc:sldMk cId="3360323603" sldId="283"/>
         </pc:sldMkLst>
+        <pc:spChg chg="mod ord">
+          <ac:chgData name="Kuykendall, Jon  (DOH)" userId="d913a90c-1e09-43d3-802c-6017c2088196" providerId="ADAL" clId="{22D6D971-81A8-444C-9D91-5577FA95D32F}" dt="2023-07-31T22:20:19.938" v="1148" actId="26606"/>
+          <ac:spMkLst>
+            <pc:docMk/>
+            <pc:sldMk cId="3360323603" sldId="283"/>
+            <ac:spMk id="5" creationId="{1FA3AFFC-FE3B-5A1B-EA07-724A317B203A}"/>
+          </ac:spMkLst>
+        </pc:spChg>
+        <pc:spChg chg="add del">
+          <ac:chgData name="Kuykendall, Jon  (DOH)" userId="d913a90c-1e09-43d3-802c-6017c2088196" providerId="ADAL" clId="{22D6D971-81A8-444C-9D91-5577FA95D32F}" dt="2023-07-31T22:20:19.938" v="1148" actId="26606"/>
+          <ac:spMkLst>
+            <pc:docMk/>
+            <pc:sldMk cId="3360323603" sldId="283"/>
+            <ac:spMk id="14" creationId="{FD89322B-D5EE-4F94-A9CB-0727D3EB4C5F}"/>
+          </ac:spMkLst>
+        </pc:spChg>
+        <pc:spChg chg="add">
+          <ac:chgData name="Kuykendall, Jon  (DOH)" userId="d913a90c-1e09-43d3-802c-6017c2088196" providerId="ADAL" clId="{22D6D971-81A8-444C-9D91-5577FA95D32F}" dt="2023-07-31T22:20:19.938" v="1148" actId="26606"/>
+          <ac:spMkLst>
+            <pc:docMk/>
+            <pc:sldMk cId="3360323603" sldId="283"/>
+            <ac:spMk id="29" creationId="{53D1018B-412F-4D92-8F80-6D1E41C88D94}"/>
+          </ac:spMkLst>
+        </pc:spChg>
+        <pc:picChg chg="add mod">
+          <ac:chgData name="Kuykendall, Jon  (DOH)" userId="d913a90c-1e09-43d3-802c-6017c2088196" providerId="ADAL" clId="{22D6D971-81A8-444C-9D91-5577FA95D32F}" dt="2023-07-31T22:20:41.653" v="1150" actId="1076"/>
+          <ac:picMkLst>
+            <pc:docMk/>
+            <pc:sldMk cId="3360323603" sldId="283"/>
+            <ac:picMk id="3" creationId="{9305566C-452C-7316-AF0B-016E68D39A50}"/>
+          </ac:picMkLst>
+        </pc:picChg>
+        <pc:picChg chg="add del">
+          <ac:chgData name="Kuykendall, Jon  (DOH)" userId="d913a90c-1e09-43d3-802c-6017c2088196" providerId="ADAL" clId="{22D6D971-81A8-444C-9D91-5577FA95D32F}" dt="2023-07-31T22:20:19.938" v="1148" actId="26606"/>
+          <ac:picMkLst>
+            <pc:docMk/>
+            <pc:sldMk cId="3360323603" sldId="283"/>
+            <ac:picMk id="10" creationId="{80DF651B-0216-4CE1-9993-9C81C4629822}"/>
+          </ac:picMkLst>
+        </pc:picChg>
+        <pc:picChg chg="add del">
+          <ac:chgData name="Kuykendall, Jon  (DOH)" userId="d913a90c-1e09-43d3-802c-6017c2088196" providerId="ADAL" clId="{22D6D971-81A8-444C-9D91-5577FA95D32F}" dt="2023-07-31T22:20:19.938" v="1148" actId="26606"/>
+          <ac:picMkLst>
+            <pc:docMk/>
+            <pc:sldMk cId="3360323603" sldId="283"/>
+            <ac:picMk id="12" creationId="{AB703B97-31D0-4D92-B70B-F64FFB490256}"/>
+          </ac:picMkLst>
+        </pc:picChg>
+        <pc:picChg chg="add del">
+          <ac:chgData name="Kuykendall, Jon  (DOH)" userId="d913a90c-1e09-43d3-802c-6017c2088196" providerId="ADAL" clId="{22D6D971-81A8-444C-9D91-5577FA95D32F}" dt="2023-07-31T22:20:19.938" v="1148" actId="26606"/>
+          <ac:picMkLst>
+            <pc:docMk/>
+            <pc:sldMk cId="3360323603" sldId="283"/>
+            <ac:picMk id="16" creationId="{6C632D00-0F7A-4464-BEBD-3F8ED9DEEE7F}"/>
+          </ac:picMkLst>
+        </pc:picChg>
+        <pc:picChg chg="add del">
+          <ac:chgData name="Kuykendall, Jon  (DOH)" userId="d913a90c-1e09-43d3-802c-6017c2088196" providerId="ADAL" clId="{22D6D971-81A8-444C-9D91-5577FA95D32F}" dt="2023-07-31T22:20:19.938" v="1148" actId="26606"/>
+          <ac:picMkLst>
+            <pc:docMk/>
+            <pc:sldMk cId="3360323603" sldId="283"/>
+            <ac:picMk id="20" creationId="{9A94445F-58D5-4560-8344-57985EDB38B1}"/>
+          </ac:picMkLst>
+        </pc:picChg>
+        <pc:picChg chg="add">
+          <ac:chgData name="Kuykendall, Jon  (DOH)" userId="d913a90c-1e09-43d3-802c-6017c2088196" providerId="ADAL" clId="{22D6D971-81A8-444C-9D91-5577FA95D32F}" dt="2023-07-31T22:20:19.938" v="1148" actId="26606"/>
+          <ac:picMkLst>
+            <pc:docMk/>
+            <pc:sldMk cId="3360323603" sldId="283"/>
+            <ac:picMk id="25" creationId="{E43006C0-9CF0-4AD0-9C72-B3F9942A80C0}"/>
+          </ac:picMkLst>
+        </pc:picChg>
+        <pc:picChg chg="add">
+          <ac:chgData name="Kuykendall, Jon  (DOH)" userId="d913a90c-1e09-43d3-802c-6017c2088196" providerId="ADAL" clId="{22D6D971-81A8-444C-9D91-5577FA95D32F}" dt="2023-07-31T22:20:19.938" v="1148" actId="26606"/>
+          <ac:picMkLst>
+            <pc:docMk/>
+            <pc:sldMk cId="3360323603" sldId="283"/>
+            <ac:picMk id="27" creationId="{78A20B43-EA35-4D51-8E25-05F8B334E9EC}"/>
+          </ac:picMkLst>
+        </pc:picChg>
+        <pc:picChg chg="add">
+          <ac:chgData name="Kuykendall, Jon  (DOH)" userId="d913a90c-1e09-43d3-802c-6017c2088196" providerId="ADAL" clId="{22D6D971-81A8-444C-9D91-5577FA95D32F}" dt="2023-07-31T22:20:19.938" v="1148" actId="26606"/>
+          <ac:picMkLst>
+            <pc:docMk/>
+            <pc:sldMk cId="3360323603" sldId="283"/>
+            <ac:picMk id="31" creationId="{B59371E8-E3A5-457E-A234-8A4F8B8256C2}"/>
+          </ac:picMkLst>
+        </pc:picChg>
+        <pc:picChg chg="add">
+          <ac:chgData name="Kuykendall, Jon  (DOH)" userId="d913a90c-1e09-43d3-802c-6017c2088196" providerId="ADAL" clId="{22D6D971-81A8-444C-9D91-5577FA95D32F}" dt="2023-07-31T22:20:19.938" v="1148" actId="26606"/>
+          <ac:picMkLst>
+            <pc:docMk/>
+            <pc:sldMk cId="3360323603" sldId="283"/>
+            <ac:picMk id="33" creationId="{4108FAA8-9416-4584-94E0-E60C0EF6F225}"/>
+          </ac:picMkLst>
+        </pc:picChg>
+        <pc:cxnChg chg="add del">
+          <ac:chgData name="Kuykendall, Jon  (DOH)" userId="d913a90c-1e09-43d3-802c-6017c2088196" providerId="ADAL" clId="{22D6D971-81A8-444C-9D91-5577FA95D32F}" dt="2023-07-31T22:20:19.938" v="1148" actId="26606"/>
+          <ac:cxnSpMkLst>
+            <pc:docMk/>
+            <pc:sldMk cId="3360323603" sldId="283"/>
+            <ac:cxnSpMk id="18" creationId="{C6CBDAC7-966A-4EED-8916-387BC2F4F21E}"/>
+          </ac:cxnSpMkLst>
+        </pc:cxnChg>
       </pc:sldChg>
       <pc:sldChg chg="modSp new mod">
         <pc:chgData name="Kuykendall, Jon  (DOH)" userId="d913a90c-1e09-43d3-802c-6017c2088196" providerId="ADAL" clId="{22D6D971-81A8-444C-9D91-5577FA95D32F}" dt="2023-07-31T22:21:24.146" v="1152" actId="20577"/>
@@ -446,6 +1509,22 @@
           <pc:docMk/>
           <pc:sldMk cId="4258360163" sldId="284"/>
         </pc:sldMkLst>
+        <pc:spChg chg="mod">
+          <ac:chgData name="Kuykendall, Jon  (DOH)" userId="d913a90c-1e09-43d3-802c-6017c2088196" providerId="ADAL" clId="{22D6D971-81A8-444C-9D91-5577FA95D32F}" dt="2023-07-31T21:46:29.310" v="545" actId="1076"/>
+          <ac:spMkLst>
+            <pc:docMk/>
+            <pc:sldMk cId="4258360163" sldId="284"/>
+            <ac:spMk id="2" creationId="{9317C84A-D64C-BBC0-1027-FCA9C56369F5}"/>
+          </ac:spMkLst>
+        </pc:spChg>
+        <pc:spChg chg="mod">
+          <ac:chgData name="Kuykendall, Jon  (DOH)" userId="d913a90c-1e09-43d3-802c-6017c2088196" providerId="ADAL" clId="{22D6D971-81A8-444C-9D91-5577FA95D32F}" dt="2023-07-31T22:21:24.146" v="1152" actId="20577"/>
+          <ac:spMkLst>
+            <pc:docMk/>
+            <pc:sldMk cId="4258360163" sldId="284"/>
+            <ac:spMk id="3" creationId="{05BC1B72-11BA-B8CD-3C19-A07E9E3DCA07}"/>
+          </ac:spMkLst>
+        </pc:spChg>
       </pc:sldChg>
     </pc:docChg>
   </pc:docChgLst>
@@ -623,7 +1702,7 @@
           <a:p>
             <a:fld id="{48A87A34-81AB-432B-8DAE-1953F412C126}" type="datetimeFigureOut">
               <a:rPr lang="en-US" dirty="0"/>
-              <a:t>8/11/2025</a:t>
+              <a:t>10/18/2023</a:t>
             </a:fld>
             <a:endParaRPr lang="en-US" dirty="0"/>
           </a:p>
@@ -933,7 +2012,7 @@
           <a:p>
             <a:fld id="{48A87A34-81AB-432B-8DAE-1953F412C126}" type="datetimeFigureOut">
               <a:rPr lang="en-US" dirty="0"/>
-              <a:t>8/11/2025</a:t>
+              <a:t>10/18/2023</a:t>
             </a:fld>
             <a:endParaRPr lang="en-US" dirty="0"/>
           </a:p>
@@ -1150,7 +2229,7 @@
           <a:p>
             <a:fld id="{48A87A34-81AB-432B-8DAE-1953F412C126}" type="datetimeFigureOut">
               <a:rPr lang="en-US" dirty="0"/>
-              <a:t>8/11/2025</a:t>
+              <a:t>10/18/2023</a:t>
             </a:fld>
             <a:endParaRPr lang="en-US" dirty="0"/>
           </a:p>
@@ -1436,7 +2515,7 @@
           <a:p>
             <a:fld id="{48A87A34-81AB-432B-8DAE-1953F412C126}" type="datetimeFigureOut">
               <a:rPr lang="en-US" dirty="0"/>
-              <a:t>8/11/2025</a:t>
+              <a:t>10/18/2023</a:t>
             </a:fld>
             <a:endParaRPr lang="en-US" dirty="0"/>
           </a:p>
@@ -1885,7 +2964,7 @@
           <a:p>
             <a:fld id="{48A87A34-81AB-432B-8DAE-1953F412C126}" type="datetimeFigureOut">
               <a:rPr lang="en-US" dirty="0"/>
-              <a:t>8/11/2025</a:t>
+              <a:t>10/18/2023</a:t>
             </a:fld>
             <a:endParaRPr lang="en-US" dirty="0"/>
           </a:p>
@@ -2456,7 +3535,7 @@
           <a:p>
             <a:fld id="{48A87A34-81AB-432B-8DAE-1953F412C126}" type="datetimeFigureOut">
               <a:rPr lang="en-US" dirty="0"/>
-              <a:t>8/11/2025</a:t>
+              <a:t>10/18/2023</a:t>
             </a:fld>
             <a:endParaRPr lang="en-US" dirty="0"/>
           </a:p>
@@ -3312,7 +4391,7 @@
           <a:p>
             <a:fld id="{48A87A34-81AB-432B-8DAE-1953F412C126}" type="datetimeFigureOut">
               <a:rPr lang="en-US" dirty="0"/>
-              <a:t>8/11/2025</a:t>
+              <a:t>10/18/2023</a:t>
             </a:fld>
             <a:endParaRPr lang="en-US" dirty="0"/>
           </a:p>
@@ -3512,7 +4591,7 @@
           <a:p>
             <a:fld id="{48A87A34-81AB-432B-8DAE-1953F412C126}" type="datetimeFigureOut">
               <a:rPr lang="en-US" dirty="0"/>
-              <a:t>8/11/2025</a:t>
+              <a:t>10/18/2023</a:t>
             </a:fld>
             <a:endParaRPr lang="en-US" dirty="0"/>
           </a:p>
@@ -3721,7 +4800,7 @@
           <a:p>
             <a:fld id="{48A87A34-81AB-432B-8DAE-1953F412C126}" type="datetimeFigureOut">
               <a:rPr lang="en-US" dirty="0"/>
-              <a:t>8/11/2025</a:t>
+              <a:t>10/18/2023</a:t>
             </a:fld>
             <a:endParaRPr lang="en-US" dirty="0"/>
           </a:p>
@@ -3921,7 +5000,7 @@
           <a:p>
             <a:fld id="{48A87A34-81AB-432B-8DAE-1953F412C126}" type="datetimeFigureOut">
               <a:rPr lang="en-US" dirty="0"/>
-              <a:t>8/11/2025</a:t>
+              <a:t>10/18/2023</a:t>
             </a:fld>
             <a:endParaRPr lang="en-US" dirty="0"/>
           </a:p>
@@ -4196,7 +5275,7 @@
           <a:p>
             <a:fld id="{48A87A34-81AB-432B-8DAE-1953F412C126}" type="datetimeFigureOut">
               <a:rPr lang="en-US" dirty="0"/>
-              <a:t>8/11/2025</a:t>
+              <a:t>10/18/2023</a:t>
             </a:fld>
             <a:endParaRPr lang="en-US" dirty="0"/>
           </a:p>
@@ -4458,7 +5537,7 @@
           <a:p>
             <a:fld id="{48A87A34-81AB-432B-8DAE-1953F412C126}" type="datetimeFigureOut">
               <a:rPr lang="en-US" dirty="0"/>
-              <a:t>8/11/2025</a:t>
+              <a:t>10/18/2023</a:t>
             </a:fld>
             <a:endParaRPr lang="en-US" dirty="0"/>
           </a:p>
@@ -4868,7 +5947,7 @@
           <a:p>
             <a:fld id="{48A87A34-81AB-432B-8DAE-1953F412C126}" type="datetimeFigureOut">
               <a:rPr lang="en-US" dirty="0"/>
-              <a:t>8/11/2025</a:t>
+              <a:t>10/18/2023</a:t>
             </a:fld>
             <a:endParaRPr lang="en-US" dirty="0"/>
           </a:p>
@@ -5011,7 +6090,7 @@
           <a:p>
             <a:fld id="{48A87A34-81AB-432B-8DAE-1953F412C126}" type="datetimeFigureOut">
               <a:rPr lang="en-US" dirty="0"/>
-              <a:t>8/11/2025</a:t>
+              <a:t>10/18/2023</a:t>
             </a:fld>
             <a:endParaRPr lang="en-US" dirty="0"/>
           </a:p>
@@ -5131,7 +6210,7 @@
           <a:p>
             <a:fld id="{48A87A34-81AB-432B-8DAE-1953F412C126}" type="datetimeFigureOut">
               <a:rPr lang="en-US" dirty="0"/>
-              <a:t>8/11/2025</a:t>
+              <a:t>10/18/2023</a:t>
             </a:fld>
             <a:endParaRPr lang="en-US" dirty="0"/>
           </a:p>
@@ -5405,7 +6484,7 @@
           <a:p>
             <a:fld id="{48A87A34-81AB-432B-8DAE-1953F412C126}" type="datetimeFigureOut">
               <a:rPr lang="en-US" dirty="0"/>
-              <a:t>8/11/2025</a:t>
+              <a:t>10/18/2023</a:t>
             </a:fld>
             <a:endParaRPr lang="en-US" dirty="0"/>
           </a:p>
@@ -5715,7 +6794,7 @@
           <a:p>
             <a:fld id="{48A87A34-81AB-432B-8DAE-1953F412C126}" type="datetimeFigureOut">
               <a:rPr lang="en-US" dirty="0"/>
-              <a:t>8/11/2025</a:t>
+              <a:t>10/18/2023</a:t>
             </a:fld>
             <a:endParaRPr lang="en-US" dirty="0"/>
           </a:p>
@@ -5964,7 +7043,7 @@
             <a:fld id="{48A87A34-81AB-432B-8DAE-1953F412C126}" type="datetimeFigureOut">
               <a:rPr lang="en-US" dirty="0"/>
               <a:pPr/>
-              <a:t>8/11/2025</a:t>
+              <a:t>10/18/2023</a:t>
             </a:fld>
             <a:endParaRPr lang="en-US" dirty="0"/>
           </a:p>
@@ -13019,34 +14098,83 @@
 </file>
 
 <file path=customXml/item1.xml><?xml version="1.0" encoding="utf-8"?>
-<p:properties xmlns:p="http://schemas.microsoft.com/office/2006/metadata/properties" xmlns:xsi="http://www.w3.org/2001/XMLSchema-instance" xmlns:pc="http://schemas.microsoft.com/office/infopath/2007/PartnerControls">
-  <documentManagement/>
-</p:properties>
+<?mso-contentType ?>
+<spe:Receivers xmlns:spe="http://schemas.microsoft.com/sharepoint/events">
+  <Receiver>
+    <Name>Document ID Generator</Name>
+    <Synchronization>Synchronous</Synchronization>
+    <Type>10001</Type>
+    <SequenceNumber>1000</SequenceNumber>
+    <Url/>
+    <Assembly>Microsoft.Office.DocumentManagement, Version=16.0.0.0, Culture=neutral, PublicKeyToken=71e9bce111e9429c</Assembly>
+    <Class>Microsoft.Office.DocumentManagement.Internal.DocIdHandler</Class>
+    <Data/>
+    <Filter/>
+  </Receiver>
+  <Receiver>
+    <Name>Document ID Generator</Name>
+    <Synchronization>Synchronous</Synchronization>
+    <Type>10002</Type>
+    <SequenceNumber>1001</SequenceNumber>
+    <Url/>
+    <Assembly>Microsoft.Office.DocumentManagement, Version=16.0.0.0, Culture=neutral, PublicKeyToken=71e9bce111e9429c</Assembly>
+    <Class>Microsoft.Office.DocumentManagement.Internal.DocIdHandler</Class>
+    <Data/>
+    <Filter/>
+  </Receiver>
+  <Receiver>
+    <Name>Document ID Generator</Name>
+    <Synchronization>Synchronous</Synchronization>
+    <Type>10004</Type>
+    <SequenceNumber>1002</SequenceNumber>
+    <Url/>
+    <Assembly>Microsoft.Office.DocumentManagement, Version=16.0.0.0, Culture=neutral, PublicKeyToken=71e9bce111e9429c</Assembly>
+    <Class>Microsoft.Office.DocumentManagement.Internal.DocIdHandler</Class>
+    <Data/>
+    <Filter/>
+  </Receiver>
+  <Receiver>
+    <Name>Document ID Generator</Name>
+    <Synchronization>Synchronous</Synchronization>
+    <Type>10006</Type>
+    <SequenceNumber>1003</SequenceNumber>
+    <Url/>
+    <Assembly>Microsoft.Office.DocumentManagement, Version=16.0.0.0, Culture=neutral, PublicKeyToken=71e9bce111e9429c</Assembly>
+    <Class>Microsoft.Office.DocumentManagement.Internal.DocIdHandler</Class>
+    <Data/>
+    <Filter/>
+  </Receiver>
+</spe:Receivers>
 </file>
 
 <file path=customXml/item2.xml><?xml version="1.0" encoding="utf-8"?>
-<?mso-contentType ?>
-<FormTemplates xmlns="http://schemas.microsoft.com/sharepoint/v3/contenttype/forms">
-  <Display>DocumentLibraryForm</Display>
-  <Edit>DocumentLibraryForm</Edit>
-  <New>DocumentLibraryForm</New>
-</FormTemplates>
-</file>
-
-<file path=customXml/item3.xml><?xml version="1.0" encoding="utf-8"?>
-<ct:contentTypeSchema xmlns:ct="http://schemas.microsoft.com/office/2006/metadata/contentType" xmlns:ma="http://schemas.microsoft.com/office/2006/metadata/properties/metaAttributes" ct:_="" ma:_="" ma:contentTypeName="Document" ma:contentTypeID="0x010100261AC9B43F7CBB489153C42AD9B48A5B" ma:contentTypeVersion="4" ma:contentTypeDescription="Create a new document." ma:contentTypeScope="" ma:versionID="679611060b5ca8d3b626a215b129166f">
-  <xsd:schema xmlns:xsd="http://www.w3.org/2001/XMLSchema" xmlns:xs="http://www.w3.org/2001/XMLSchema" xmlns:p="http://schemas.microsoft.com/office/2006/metadata/properties" xmlns:ns2="ff8c7a7d-32d8-4387-bde3-320c30626984" targetNamespace="http://schemas.microsoft.com/office/2006/metadata/properties" ma:root="true" ma:fieldsID="6f4c769241f82027d8e377b4000242f1" ns2:_="">
-    <xsd:import namespace="ff8c7a7d-32d8-4387-bde3-320c30626984"/>
+<ct:contentTypeSchema xmlns:ct="http://schemas.microsoft.com/office/2006/metadata/contentType" xmlns:ma="http://schemas.microsoft.com/office/2006/metadata/properties/metaAttributes" ct:_="" ma:_="" ma:contentTypeName="Document" ma:contentTypeID="0x010100521259A616EA9D478FCA5B38B8816E70" ma:contentTypeVersion="16" ma:contentTypeDescription="Create a new document." ma:contentTypeScope="" ma:versionID="6acce905dab444a11f9518c29cb9530c">
+  <xsd:schema xmlns:xsd="http://www.w3.org/2001/XMLSchema" xmlns:xs="http://www.w3.org/2001/XMLSchema" xmlns:p="http://schemas.microsoft.com/office/2006/metadata/properties" xmlns:ns1="http://schemas.microsoft.com/sharepoint/v3" xmlns:ns2="44edce67-78c8-45d2-a071-88ef6b87571e" xmlns:ns3="210c430b-7c73-4362-b414-26a4e404e526" targetNamespace="http://schemas.microsoft.com/office/2006/metadata/properties" ma:root="true" ma:fieldsID="4c93ef044fd22568d0dd2e5541278dfd" ns1:_="" ns2:_="" ns3:_="">
+    <xsd:import namespace="http://schemas.microsoft.com/sharepoint/v3"/>
+    <xsd:import namespace="44edce67-78c8-45d2-a071-88ef6b87571e"/>
+    <xsd:import namespace="210c430b-7c73-4362-b414-26a4e404e526"/>
     <xsd:element name="properties">
       <xsd:complexType>
         <xsd:sequence>
           <xsd:element name="documentManagement">
             <xsd:complexType>
               <xsd:all>
-                <xsd:element ref="ns2:MediaServiceMetadata" minOccurs="0"/>
-                <xsd:element ref="ns2:MediaServiceFastMetadata" minOccurs="0"/>
-                <xsd:element ref="ns2:MediaServiceSearchProperties" minOccurs="0"/>
-                <xsd:element ref="ns2:MediaServiceObjectDetectorVersions" minOccurs="0"/>
+                <xsd:element ref="ns2:_dlc_DocId" minOccurs="0"/>
+                <xsd:element ref="ns2:_dlc_DocIdUrl" minOccurs="0"/>
+                <xsd:element ref="ns2:_dlc_DocIdPersistId" minOccurs="0"/>
+                <xsd:element ref="ns3:Document_x0020_Type" minOccurs="0"/>
+                <xsd:element ref="ns3:Program" minOccurs="0"/>
+                <xsd:element ref="ns3:MediaServiceMetadata" minOccurs="0"/>
+                <xsd:element ref="ns3:MediaServiceFastMetadata" minOccurs="0"/>
+                <xsd:element ref="ns2:SharedWithUsers" minOccurs="0"/>
+                <xsd:element ref="ns2:SharedWithDetails" minOccurs="0"/>
+                <xsd:element ref="ns1:_ip_UnifiedCompliancePolicyProperties" minOccurs="0"/>
+                <xsd:element ref="ns1:_ip_UnifiedCompliancePolicyUIAction" minOccurs="0"/>
+                <xsd:element ref="ns3:lcf76f155ced4ddcb4097134ff3c332f" minOccurs="0"/>
+                <xsd:element ref="ns2:TaxCatchAll" minOccurs="0"/>
+                <xsd:element ref="ns3:MediaServiceGenerationTime" minOccurs="0"/>
+                <xsd:element ref="ns3:MediaServiceEventHashCode" minOccurs="0"/>
+                <xsd:element ref="ns3:MediaServiceObjectDetectorVersions" minOccurs="0"/>
               </xsd:all>
             </xsd:complexType>
           </xsd:element>
@@ -13054,25 +14182,146 @@
       </xsd:complexType>
     </xsd:element>
   </xsd:schema>
-  <xsd:schema xmlns:xsd="http://www.w3.org/2001/XMLSchema" xmlns:xs="http://www.w3.org/2001/XMLSchema" xmlns:dms="http://schemas.microsoft.com/office/2006/documentManagement/types" xmlns:pc="http://schemas.microsoft.com/office/infopath/2007/PartnerControls" targetNamespace="ff8c7a7d-32d8-4387-bde3-320c30626984" elementFormDefault="qualified">
+  <xsd:schema xmlns:xsd="http://www.w3.org/2001/XMLSchema" xmlns:xs="http://www.w3.org/2001/XMLSchema" xmlns:dms="http://schemas.microsoft.com/office/2006/documentManagement/types" xmlns:pc="http://schemas.microsoft.com/office/infopath/2007/PartnerControls" targetNamespace="http://schemas.microsoft.com/sharepoint/v3" elementFormDefault="qualified">
     <xsd:import namespace="http://schemas.microsoft.com/office/2006/documentManagement/types"/>
     <xsd:import namespace="http://schemas.microsoft.com/office/infopath/2007/PartnerControls"/>
-    <xsd:element name="MediaServiceMetadata" ma:index="8" nillable="true" ma:displayName="MediaServiceMetadata" ma:hidden="true" ma:internalName="MediaServiceMetadata" ma:readOnly="true">
+    <xsd:element name="_ip_UnifiedCompliancePolicyProperties" ma:index="17" nillable="true" ma:displayName="Unified Compliance Policy Properties" ma:hidden="true" ma:internalName="_ip_UnifiedCompliancePolicyProperties">
       <xsd:simpleType>
         <xsd:restriction base="dms:Note"/>
       </xsd:simpleType>
     </xsd:element>
-    <xsd:element name="MediaServiceFastMetadata" ma:index="9" nillable="true" ma:displayName="MediaServiceFastMetadata" ma:hidden="true" ma:internalName="MediaServiceFastMetadata" ma:readOnly="true">
+    <xsd:element name="_ip_UnifiedCompliancePolicyUIAction" ma:index="18" nillable="true" ma:displayName="Unified Compliance Policy UI Action" ma:hidden="true" ma:internalName="_ip_UnifiedCompliancePolicyUIAction">
+      <xsd:simpleType>
+        <xsd:restriction base="dms:Text"/>
+      </xsd:simpleType>
+    </xsd:element>
+  </xsd:schema>
+  <xsd:schema xmlns:xsd="http://www.w3.org/2001/XMLSchema" xmlns:xs="http://www.w3.org/2001/XMLSchema" xmlns:dms="http://schemas.microsoft.com/office/2006/documentManagement/types" xmlns:pc="http://schemas.microsoft.com/office/infopath/2007/PartnerControls" targetNamespace="44edce67-78c8-45d2-a071-88ef6b87571e" elementFormDefault="qualified">
+    <xsd:import namespace="http://schemas.microsoft.com/office/2006/documentManagement/types"/>
+    <xsd:import namespace="http://schemas.microsoft.com/office/infopath/2007/PartnerControls"/>
+    <xsd:element name="_dlc_DocId" ma:index="4" nillable="true" ma:displayName="Document ID Value" ma:description="The value of the document ID assigned to this item." ma:indexed="true" ma:internalName="_dlc_DocId" ma:readOnly="true">
+      <xsd:simpleType>
+        <xsd:restriction base="dms:Text"/>
+      </xsd:simpleType>
+    </xsd:element>
+    <xsd:element name="_dlc_DocIdUrl" ma:index="5" nillable="true" ma:displayName="Document ID" ma:description="Permanent link to this document." ma:hidden="true" ma:internalName="_dlc_DocIdUrl" ma:readOnly="true">
+      <xsd:complexType>
+        <xsd:complexContent>
+          <xsd:extension base="dms:URL">
+            <xsd:sequence>
+              <xsd:element name="Url" type="dms:ValidUrl" minOccurs="0" nillable="true"/>
+              <xsd:element name="Description" type="xsd:string" nillable="true"/>
+            </xsd:sequence>
+          </xsd:extension>
+        </xsd:complexContent>
+      </xsd:complexType>
+    </xsd:element>
+    <xsd:element name="_dlc_DocIdPersistId" ma:index="6" nillable="true" ma:displayName="Persist ID" ma:description="Keep ID on add." ma:hidden="true" ma:internalName="_dlc_DocIdPersistId" ma:readOnly="true">
+      <xsd:simpleType>
+        <xsd:restriction base="dms:Boolean"/>
+      </xsd:simpleType>
+    </xsd:element>
+    <xsd:element name="SharedWithUsers" ma:index="15" nillable="true" ma:displayName="Shared With" ma:internalName="SharedWithUsers" ma:readOnly="true">
+      <xsd:complexType>
+        <xsd:complexContent>
+          <xsd:extension base="dms:UserMulti">
+            <xsd:sequence>
+              <xsd:element name="UserInfo" minOccurs="0" maxOccurs="unbounded">
+                <xsd:complexType>
+                  <xsd:sequence>
+                    <xsd:element name="DisplayName" type="xsd:string" minOccurs="0"/>
+                    <xsd:element name="AccountId" type="dms:UserId" minOccurs="0" nillable="true"/>
+                    <xsd:element name="AccountType" type="xsd:string" minOccurs="0"/>
+                  </xsd:sequence>
+                </xsd:complexType>
+              </xsd:element>
+            </xsd:sequence>
+          </xsd:extension>
+        </xsd:complexContent>
+      </xsd:complexType>
+    </xsd:element>
+    <xsd:element name="SharedWithDetails" ma:index="16" nillable="true" ma:displayName="Shared With Details" ma:internalName="SharedWithDetails" ma:readOnly="true">
+      <xsd:simpleType>
+        <xsd:restriction base="dms:Note">
+          <xsd:maxLength value="255"/>
+        </xsd:restriction>
+      </xsd:simpleType>
+    </xsd:element>
+    <xsd:element name="TaxCatchAll" ma:index="21" nillable="true" ma:displayName="Taxonomy Catch All Column" ma:hidden="true" ma:list="{a973a1e9-c5c1-4aac-afc8-7f0ead7a09db}" ma:internalName="TaxCatchAll" ma:showField="CatchAllData" ma:web="44edce67-78c8-45d2-a071-88ef6b87571e">
+      <xsd:complexType>
+        <xsd:complexContent>
+          <xsd:extension base="dms:MultiChoiceLookup">
+            <xsd:sequence>
+              <xsd:element name="Value" type="dms:Lookup" maxOccurs="unbounded" minOccurs="0" nillable="true"/>
+            </xsd:sequence>
+          </xsd:extension>
+        </xsd:complexContent>
+      </xsd:complexType>
+    </xsd:element>
+  </xsd:schema>
+  <xsd:schema xmlns:xsd="http://www.w3.org/2001/XMLSchema" xmlns:xs="http://www.w3.org/2001/XMLSchema" xmlns:dms="http://schemas.microsoft.com/office/2006/documentManagement/types" xmlns:pc="http://schemas.microsoft.com/office/infopath/2007/PartnerControls" targetNamespace="210c430b-7c73-4362-b414-26a4e404e526" elementFormDefault="qualified">
+    <xsd:import namespace="http://schemas.microsoft.com/office/2006/documentManagement/types"/>
+    <xsd:import namespace="http://schemas.microsoft.com/office/infopath/2007/PartnerControls"/>
+    <xsd:element name="Document_x0020_Type" ma:index="7" nillable="true" ma:displayName="Document Type" ma:default="Templates" ma:format="Dropdown" ma:internalName="Document_x0020_Type" ma:readOnly="false">
+      <xsd:simpleType>
+        <xsd:union memberTypes="dms:Text">
+          <xsd:simpleType>
+            <xsd:restriction base="dms:Choice">
+              <xsd:enumeration value="Templates"/>
+              <xsd:enumeration value="Assignments"/>
+              <xsd:enumeration value="Training"/>
+              <xsd:enumeration value="Travel"/>
+            </xsd:restriction>
+          </xsd:simpleType>
+        </xsd:union>
+      </xsd:simpleType>
+    </xsd:element>
+    <xsd:element name="Program" ma:index="8" nillable="true" ma:displayName="Program" ma:internalName="Program" ma:readOnly="false">
+      <xsd:complexType>
+        <xsd:complexContent>
+          <xsd:extension base="dms:MultiChoice">
+            <xsd:sequence>
+              <xsd:element name="Value" maxOccurs="unbounded" minOccurs="0" nillable="true">
+                <xsd:simpleType>
+                  <xsd:restriction base="dms:Choice">
+                    <xsd:enumeration value="Behavioral Health Review"/>
+                    <xsd:enumeration value="Behavioral Health Investigation"/>
+                  </xsd:restriction>
+                </xsd:simpleType>
+              </xsd:element>
+            </xsd:sequence>
+          </xsd:extension>
+        </xsd:complexContent>
+      </xsd:complexType>
+    </xsd:element>
+    <xsd:element name="MediaServiceMetadata" ma:index="13" nillable="true" ma:displayName="MediaServiceMetadata" ma:hidden="true" ma:internalName="MediaServiceMetadata" ma:readOnly="true">
       <xsd:simpleType>
         <xsd:restriction base="dms:Note"/>
       </xsd:simpleType>
     </xsd:element>
-    <xsd:element name="MediaServiceSearchProperties" ma:index="10" nillable="true" ma:displayName="MediaServiceSearchProperties" ma:hidden="true" ma:internalName="MediaServiceSearchProperties" ma:readOnly="true">
+    <xsd:element name="MediaServiceFastMetadata" ma:index="14" nillable="true" ma:displayName="MediaServiceFastMetadata" ma:hidden="true" ma:internalName="MediaServiceFastMetadata" ma:readOnly="true">
       <xsd:simpleType>
         <xsd:restriction base="dms:Note"/>
       </xsd:simpleType>
     </xsd:element>
-    <xsd:element name="MediaServiceObjectDetectorVersions" ma:index="11" nillable="true" ma:displayName="MediaServiceObjectDetectorVersions" ma:hidden="true" ma:indexed="true" ma:internalName="MediaServiceObjectDetectorVersions" ma:readOnly="true">
+    <xsd:element name="lcf76f155ced4ddcb4097134ff3c332f" ma:index="20" nillable="true" ma:taxonomy="true" ma:internalName="lcf76f155ced4ddcb4097134ff3c332f" ma:taxonomyFieldName="MediaServiceImageTags" ma:displayName="Image Tags" ma:readOnly="false" ma:fieldId="{5cf76f15-5ced-4ddc-b409-7134ff3c332f}" ma:taxonomyMulti="true" ma:sspId="360a6a1c-50a4-4ec0-87e3-f00760ffe76b" ma:termSetId="09814cd3-568e-fe90-9814-8d621ff8fb84" ma:anchorId="fba54fb3-c3e1-fe81-a776-ca4b69148c4d" ma:open="true" ma:isKeyword="false">
+      <xsd:complexType>
+        <xsd:sequence>
+          <xsd:element ref="pc:Terms" minOccurs="0" maxOccurs="1"/>
+        </xsd:sequence>
+      </xsd:complexType>
+    </xsd:element>
+    <xsd:element name="MediaServiceGenerationTime" ma:index="22" nillable="true" ma:displayName="MediaServiceGenerationTime" ma:hidden="true" ma:internalName="MediaServiceGenerationTime" ma:readOnly="true">
+      <xsd:simpleType>
+        <xsd:restriction base="dms:Text"/>
+      </xsd:simpleType>
+    </xsd:element>
+    <xsd:element name="MediaServiceEventHashCode" ma:index="23" nillable="true" ma:displayName="MediaServiceEventHashCode" ma:hidden="true" ma:internalName="MediaServiceEventHashCode" ma:readOnly="true">
+      <xsd:simpleType>
+        <xsd:restriction base="dms:Text"/>
+      </xsd:simpleType>
+    </xsd:element>
+    <xsd:element name="MediaServiceObjectDetectorVersions" ma:index="24" nillable="true" ma:displayName="MediaServiceObjectDetectorVersions" ma:hidden="true" ma:indexed="true" ma:internalName="MediaServiceObjectDetectorVersions" ma:readOnly="true">
       <xsd:simpleType>
         <xsd:restriction base="dms:Text"/>
       </xsd:simpleType>
@@ -13087,8 +14336,8 @@
         <xsd:element ref="dc:creator" minOccurs="0" maxOccurs="1"/>
         <xsd:element ref="dcterms:created" minOccurs="0" maxOccurs="1"/>
         <xsd:element ref="dc:identifier" minOccurs="0" maxOccurs="1"/>
-        <xsd:element name="contentType" minOccurs="0" maxOccurs="1" type="xsd:string" ma:index="0" ma:displayName="Content Type"/>
-        <xsd:element ref="dc:title" minOccurs="0" maxOccurs="1" ma:index="4" ma:displayName="Title"/>
+        <xsd:element name="contentType" minOccurs="0" maxOccurs="1" type="xsd:string" ma:index="9" ma:displayName="Content Type"/>
+        <xsd:element ref="dc:title" minOccurs="0" maxOccurs="1" ma:index="3" ma:displayName="Title"/>
         <xsd:element ref="dc:subject" minOccurs="0" maxOccurs="1"/>
         <xsd:element ref="dc:description" minOccurs="0" maxOccurs="1"/>
         <xsd:element name="keywords" minOccurs="0" maxOccurs="1" type="xsd:string"/>
@@ -13177,38 +14426,56 @@
 </ct:contentTypeSchema>
 </file>
 
+<file path=customXml/item3.xml><?xml version="1.0" encoding="utf-8"?>
+<?mso-contentType ?>
+<FormTemplates xmlns="http://schemas.microsoft.com/sharepoint/v3/contenttype/forms">
+  <Display>DocumentLibraryForm</Display>
+  <Edit>DocumentLibraryForm</Edit>
+  <New>DocumentLibraryForm</New>
+</FormTemplates>
+</file>
+
+<file path=customXml/item4.xml><?xml version="1.0" encoding="utf-8"?>
+<p:properties xmlns:p="http://schemas.microsoft.com/office/2006/metadata/properties" xmlns:xsi="http://www.w3.org/2001/XMLSchema-instance" xmlns:pc="http://schemas.microsoft.com/office/infopath/2007/PartnerControls">
+  <documentManagement>
+    <Document_x0020_Type xmlns="210c430b-7c73-4362-b414-26a4e404e526">Training</Document_x0020_Type>
+    <_dlc_DocId xmlns="44edce67-78c8-45d2-a071-88ef6b87571e">PV25X54MA5AD-896105636-29</_dlc_DocId>
+    <_dlc_DocIdUrl xmlns="44edce67-78c8-45d2-a071-88ef6b87571e">
+      <Url>https://stateofwa.sharepoint.com/sites/DOH-hsqa/oii/_layouts/15/DocIdRedir.aspx?ID=PV25X54MA5AD-896105636-29</Url>
+      <Description>PV25X54MA5AD-896105636-29</Description>
+    </_dlc_DocIdUrl>
+    <Program xmlns="210c430b-7c73-4362-b414-26a4e404e526">
+      <Value>Behavioral Health Review</Value>
+      <Value>Behavioral Health Investigation</Value>
+    </Program>
+    <_ip_UnifiedCompliancePolicyUIAction xmlns="http://schemas.microsoft.com/sharepoint/v3" xsi:nil="true"/>
+    <_ip_UnifiedCompliancePolicyProperties xmlns="http://schemas.microsoft.com/sharepoint/v3" xsi:nil="true"/>
+    <TaxCatchAll xmlns="44edce67-78c8-45d2-a071-88ef6b87571e" xsi:nil="true"/>
+    <lcf76f155ced4ddcb4097134ff3c332f xmlns="210c430b-7c73-4362-b414-26a4e404e526">
+      <Terms xmlns="http://schemas.microsoft.com/office/infopath/2007/PartnerControls"/>
+    </lcf76f155ced4ddcb4097134ff3c332f>
+  </documentManagement>
+</p:properties>
+</file>
+
 <file path=customXml/itemProps1.xml><?xml version="1.0" encoding="utf-8"?>
-<ds:datastoreItem xmlns:ds="http://schemas.openxmlformats.org/officeDocument/2006/customXml" ds:itemID="{F49E01B9-B9B1-4F28-B6B7-11643CB889F7}">
+<ds:datastoreItem xmlns:ds="http://schemas.openxmlformats.org/officeDocument/2006/customXml" ds:itemID="{5568CC9A-2E84-4E59-B97A-21B777748F04}">
   <ds:schemaRefs>
-    <ds:schemaRef ds:uri="ff8c7a7d-32d8-4387-bde3-320c30626984"/>
-    <ds:schemaRef ds:uri="http://purl.org/dc/elements/1.1/"/>
-    <ds:schemaRef ds:uri="http://schemas.microsoft.com/office/2006/documentManagement/types"/>
-    <ds:schemaRef ds:uri="http://schemas.microsoft.com/office/infopath/2007/PartnerControls"/>
-    <ds:schemaRef ds:uri="http://purl.org/dc/terms/"/>
-    <ds:schemaRef ds:uri="http://www.w3.org/XML/1998/namespace"/>
-    <ds:schemaRef ds:uri="http://schemas.microsoft.com/office/2006/metadata/properties"/>
-    <ds:schemaRef ds:uri="http://schemas.openxmlformats.org/package/2006/metadata/core-properties"/>
-    <ds:schemaRef ds:uri="http://purl.org/dc/dcmitype/"/>
+    <ds:schemaRef ds:uri="http://schemas.microsoft.com/sharepoint/events"/>
   </ds:schemaRefs>
 </ds:datastoreItem>
 </file>
 
 <file path=customXml/itemProps2.xml><?xml version="1.0" encoding="utf-8"?>
-<ds:datastoreItem xmlns:ds="http://schemas.openxmlformats.org/officeDocument/2006/customXml" ds:itemID="{89886310-AEE9-4AA1-A7B7-DBAB18C06E96}">
-  <ds:schemaRefs>
-    <ds:schemaRef ds:uri="http://schemas.microsoft.com/sharepoint/v3/contenttype/forms"/>
-  </ds:schemaRefs>
-</ds:datastoreItem>
-</file>
-
-<file path=customXml/itemProps3.xml><?xml version="1.0" encoding="utf-8"?>
-<ds:datastoreItem xmlns:ds="http://schemas.openxmlformats.org/officeDocument/2006/customXml" ds:itemID="{785EBB7A-4D5F-4F74-A990-FA22D881299B}">
+<ds:datastoreItem xmlns:ds="http://schemas.openxmlformats.org/officeDocument/2006/customXml" ds:itemID="{E186C78E-98FE-44B5-91E0-23C2E8C84DF4}">
   <ds:schemaRefs>
     <ds:schemaRef ds:uri="http://schemas.microsoft.com/office/2006/metadata/contentType"/>
     <ds:schemaRef ds:uri="http://schemas.microsoft.com/office/2006/metadata/properties/metaAttributes"/>
     <ds:schemaRef ds:uri="http://www.w3.org/2001/XMLSchema"/>
     <ds:schemaRef ds:uri="http://schemas.microsoft.com/office/2006/metadata/properties"/>
-    <ds:schemaRef ds:uri="ff8c7a7d-32d8-4387-bde3-320c30626984"/>
+    <ds:schemaRef ds:uri="http://schemas.microsoft.com/sharepoint/v3"/>
+    <ds:schemaRef ds:uri="44edce67-78c8-45d2-a071-88ef6b87571e"/>
+    <ds:schemaRef ds:uri="210c430b-7c73-4362-b414-26a4e404e526"/>
     <ds:schemaRef ds:uri="http://schemas.microsoft.com/office/2006/documentManagement/types"/>
     <ds:schemaRef ds:uri="http://schemas.microsoft.com/office/infopath/2007/PartnerControls"/>
     <ds:schemaRef ds:uri="http://schemas.openxmlformats.org/package/2006/metadata/core-properties"/>
@@ -13217,4 +14484,30 @@
     <ds:schemaRef ds:uri="http://schemas.microsoft.com/internal/obd"/>
   </ds:schemaRefs>
 </ds:datastoreItem>
+</file>
+
+<file path=customXml/itemProps3.xml><?xml version="1.0" encoding="utf-8"?>
+<ds:datastoreItem xmlns:ds="http://schemas.openxmlformats.org/officeDocument/2006/customXml" ds:itemID="{89886310-AEE9-4AA1-A7B7-DBAB18C06E96}">
+  <ds:schemaRefs>
+    <ds:schemaRef ds:uri="http://schemas.microsoft.com/sharepoint/v3/contenttype/forms"/>
+  </ds:schemaRefs>
+</ds:datastoreItem>
+</file>
+
+<file path=customXml/itemProps4.xml><?xml version="1.0" encoding="utf-8"?>
+<ds:datastoreItem xmlns:ds="http://schemas.openxmlformats.org/officeDocument/2006/customXml" ds:itemID="{F49E01B9-B9B1-4F28-B6B7-11643CB889F7}">
+  <ds:schemaRefs>
+    <ds:schemaRef ds:uri="http://purl.org/dc/elements/1.1/"/>
+    <ds:schemaRef ds:uri="http://schemas.microsoft.com/office/2006/documentManagement/types"/>
+    <ds:schemaRef ds:uri="http://schemas.openxmlformats.org/package/2006/metadata/core-properties"/>
+    <ds:schemaRef ds:uri="http://purl.org/dc/terms/"/>
+    <ds:schemaRef ds:uri="http://schemas.microsoft.com/sharepoint/v3"/>
+    <ds:schemaRef ds:uri="http://purl.org/dc/dcmitype/"/>
+    <ds:schemaRef ds:uri="http://www.w3.org/XML/1998/namespace"/>
+    <ds:schemaRef ds:uri="http://schemas.microsoft.com/office/infopath/2007/PartnerControls"/>
+    <ds:schemaRef ds:uri="210c430b-7c73-4362-b414-26a4e404e526"/>
+    <ds:schemaRef ds:uri="44edce67-78c8-45d2-a071-88ef6b87571e"/>
+    <ds:schemaRef ds:uri="http://schemas.microsoft.com/office/2006/metadata/properties"/>
+  </ds:schemaRefs>
+</ds:datastoreItem>
 </file>
</xml_diff>